<commit_message>
update figures and scripts
</commit_message>
<xml_diff>
--- a/figures/illustration.pptx
+++ b/figures/illustration.pptx
@@ -206,7 +206,7 @@
           <a:p>
             <a:fld id="{38AF2874-9575-D34A-BA81-DFC982CA5986}" type="datetimeFigureOut">
               <a:rPr lang="en-US" smtClean="0"/>
-              <a:t>7/17/26</a:t>
+              <a:t>7/20/26</a:t>
             </a:fld>
             <a:endParaRPr lang="en-US"/>
           </a:p>
@@ -788,7 +788,7 @@
           <a:p>
             <a:fld id="{00A1D771-DF29-AD44-968A-4E28D522DB9C}" type="datetimeFigureOut">
               <a:rPr lang="en-US" smtClean="0"/>
-              <a:t>7/17/26</a:t>
+              <a:t>7/20/26</a:t>
             </a:fld>
             <a:endParaRPr lang="en-US"/>
           </a:p>
@@ -986,7 +986,7 @@
           <a:p>
             <a:fld id="{00A1D771-DF29-AD44-968A-4E28D522DB9C}" type="datetimeFigureOut">
               <a:rPr lang="en-US" smtClean="0"/>
-              <a:t>7/17/26</a:t>
+              <a:t>7/20/26</a:t>
             </a:fld>
             <a:endParaRPr lang="en-US"/>
           </a:p>
@@ -1194,7 +1194,7 @@
           <a:p>
             <a:fld id="{00A1D771-DF29-AD44-968A-4E28D522DB9C}" type="datetimeFigureOut">
               <a:rPr lang="en-US" smtClean="0"/>
-              <a:t>7/17/26</a:t>
+              <a:t>7/20/26</a:t>
             </a:fld>
             <a:endParaRPr lang="en-US"/>
           </a:p>
@@ -1392,7 +1392,7 @@
           <a:p>
             <a:fld id="{00A1D771-DF29-AD44-968A-4E28D522DB9C}" type="datetimeFigureOut">
               <a:rPr lang="en-US" smtClean="0"/>
-              <a:t>7/17/26</a:t>
+              <a:t>7/20/26</a:t>
             </a:fld>
             <a:endParaRPr lang="en-US"/>
           </a:p>
@@ -1667,7 +1667,7 @@
           <a:p>
             <a:fld id="{00A1D771-DF29-AD44-968A-4E28D522DB9C}" type="datetimeFigureOut">
               <a:rPr lang="en-US" smtClean="0"/>
-              <a:t>7/17/26</a:t>
+              <a:t>7/20/26</a:t>
             </a:fld>
             <a:endParaRPr lang="en-US"/>
           </a:p>
@@ -1932,7 +1932,7 @@
           <a:p>
             <a:fld id="{00A1D771-DF29-AD44-968A-4E28D522DB9C}" type="datetimeFigureOut">
               <a:rPr lang="en-US" smtClean="0"/>
-              <a:t>7/17/26</a:t>
+              <a:t>7/20/26</a:t>
             </a:fld>
             <a:endParaRPr lang="en-US"/>
           </a:p>
@@ -2344,7 +2344,7 @@
           <a:p>
             <a:fld id="{00A1D771-DF29-AD44-968A-4E28D522DB9C}" type="datetimeFigureOut">
               <a:rPr lang="en-US" smtClean="0"/>
-              <a:t>7/17/26</a:t>
+              <a:t>7/20/26</a:t>
             </a:fld>
             <a:endParaRPr lang="en-US"/>
           </a:p>
@@ -2485,7 +2485,7 @@
           <a:p>
             <a:fld id="{00A1D771-DF29-AD44-968A-4E28D522DB9C}" type="datetimeFigureOut">
               <a:rPr lang="en-US" smtClean="0"/>
-              <a:t>7/17/26</a:t>
+              <a:t>7/20/26</a:t>
             </a:fld>
             <a:endParaRPr lang="en-US"/>
           </a:p>
@@ -2598,7 +2598,7 @@
           <a:p>
             <a:fld id="{00A1D771-DF29-AD44-968A-4E28D522DB9C}" type="datetimeFigureOut">
               <a:rPr lang="en-US" smtClean="0"/>
-              <a:t>7/17/26</a:t>
+              <a:t>7/20/26</a:t>
             </a:fld>
             <a:endParaRPr lang="en-US"/>
           </a:p>
@@ -2909,7 +2909,7 @@
           <a:p>
             <a:fld id="{00A1D771-DF29-AD44-968A-4E28D522DB9C}" type="datetimeFigureOut">
               <a:rPr lang="en-US" smtClean="0"/>
-              <a:t>7/17/26</a:t>
+              <a:t>7/20/26</a:t>
             </a:fld>
             <a:endParaRPr lang="en-US"/>
           </a:p>
@@ -3197,7 +3197,7 @@
           <a:p>
             <a:fld id="{00A1D771-DF29-AD44-968A-4E28D522DB9C}" type="datetimeFigureOut">
               <a:rPr lang="en-US" smtClean="0"/>
-              <a:t>7/17/26</a:t>
+              <a:t>7/20/26</a:t>
             </a:fld>
             <a:endParaRPr lang="en-US"/>
           </a:p>
@@ -3438,7 +3438,7 @@
           <a:p>
             <a:fld id="{00A1D771-DF29-AD44-968A-4E28D522DB9C}" type="datetimeFigureOut">
               <a:rPr lang="en-US" smtClean="0"/>
-              <a:t>7/17/26</a:t>
+              <a:t>7/20/26</a:t>
             </a:fld>
             <a:endParaRPr lang="en-US"/>
           </a:p>
@@ -7974,8 +7974,8 @@
                 </p:sp>
               </mc:Fallback>
             </mc:AlternateContent>
-            <mc:AlternateContent xmlns:mc="http://schemas.openxmlformats.org/markup-compatibility/2006">
-              <mc:Choice xmlns:a14="http://schemas.microsoft.com/office/drawing/2010/main" Requires="a14">
+            <mc:AlternateContent xmlns:mc="http://schemas.openxmlformats.org/markup-compatibility/2006" xmlns:a14="http://schemas.microsoft.com/office/drawing/2010/main">
+              <mc:Choice Requires="a14">
                 <p:sp>
                   <p:nvSpPr>
                     <p:cNvPr id="51" name="TextBox 50">
@@ -8063,7 +8063,7 @@
                   </p:txBody>
                 </p:sp>
               </mc:Choice>
-              <mc:Fallback>
+              <mc:Fallback xmlns="">
                 <p:sp>
                   <p:nvSpPr>
                     <p:cNvPr id="51" name="TextBox 50">
@@ -9353,1704 +9353,1775 @@
           <a:chExt cx="0" cy="0"/>
         </a:xfrm>
       </p:grpSpPr>
-      <p:sp>
-        <p:nvSpPr>
-          <p:cNvPr id="2" name="Rounded Rectangle 1">
+      <p:grpSp>
+        <p:nvGrpSpPr>
+          <p:cNvPr id="27" name="Group 26">
             <a:extLst>
               <a:ext uri="{FF2B5EF4-FFF2-40B4-BE49-F238E27FC236}">
-                <a16:creationId xmlns:a16="http://schemas.microsoft.com/office/drawing/2014/main" id="{73E9D10A-E087-09C4-115A-D11F25511C77}"/>
+                <a16:creationId xmlns:a16="http://schemas.microsoft.com/office/drawing/2014/main" id="{A2B79385-3E0C-50BC-2829-EDDA9A818950}"/>
               </a:ext>
             </a:extLst>
           </p:cNvPr>
-          <p:cNvSpPr/>
+          <p:cNvGrpSpPr/>
           <p:nvPr/>
-        </p:nvSpPr>
-        <p:spPr>
+        </p:nvGrpSpPr>
+        <p:grpSpPr>
           <a:xfrm>
-            <a:off x="4289502" y="1724543"/>
-            <a:ext cx="3612996" cy="802888"/>
+            <a:off x="3275930" y="1724543"/>
+            <a:ext cx="4626568" cy="3357070"/>
+            <a:chOff x="3275930" y="1724543"/>
+            <a:chExt cx="4626568" cy="3357070"/>
           </a:xfrm>
-          <a:prstGeom prst="roundRect">
-            <a:avLst/>
-          </a:prstGeom>
-          <a:solidFill>
-            <a:schemeClr val="bg2"/>
-          </a:solidFill>
-          <a:ln>
+        </p:grpSpPr>
+        <p:sp>
+          <p:nvSpPr>
+            <p:cNvPr id="2" name="Rounded Rectangle 1">
+              <a:extLst>
+                <a:ext uri="{FF2B5EF4-FFF2-40B4-BE49-F238E27FC236}">
+                  <a16:creationId xmlns:a16="http://schemas.microsoft.com/office/drawing/2014/main" id="{73E9D10A-E087-09C4-115A-D11F25511C77}"/>
+                </a:ext>
+              </a:extLst>
+            </p:cNvPr>
+            <p:cNvSpPr/>
+            <p:nvPr/>
+          </p:nvSpPr>
+          <p:spPr>
+            <a:xfrm>
+              <a:off x="4289502" y="1724543"/>
+              <a:ext cx="3612996" cy="802888"/>
+            </a:xfrm>
+            <a:prstGeom prst="roundRect">
+              <a:avLst/>
+            </a:prstGeom>
             <a:solidFill>
               <a:schemeClr val="bg2"/>
             </a:solidFill>
-          </a:ln>
-        </p:spPr>
-        <p:style>
-          <a:lnRef idx="2">
-            <a:schemeClr val="accent1">
-              <a:shade val="15000"/>
-            </a:schemeClr>
-          </a:lnRef>
-          <a:fillRef idx="1">
-            <a:schemeClr val="accent1"/>
-          </a:fillRef>
-          <a:effectRef idx="0">
-            <a:schemeClr val="accent1"/>
-          </a:effectRef>
-          <a:fontRef idx="minor">
-            <a:schemeClr val="lt1"/>
-          </a:fontRef>
-        </p:style>
-        <p:txBody>
-          <a:bodyPr rtlCol="0" anchor="ctr"/>
-          <a:lstStyle/>
-          <a:p>
-            <a:pPr algn="ctr"/>
-            <a:endParaRPr lang="en-US" dirty="0"/>
-          </a:p>
-        </p:txBody>
-      </p:sp>
-      <p:pic>
-        <p:nvPicPr>
-          <p:cNvPr id="3" name="Picture 2">
-            <a:extLst>
-              <a:ext uri="{FF2B5EF4-FFF2-40B4-BE49-F238E27FC236}">
-                <a16:creationId xmlns:a16="http://schemas.microsoft.com/office/drawing/2014/main" id="{3DA09D05-66BA-2EAB-4EE0-D91C6DF698DB}"/>
-              </a:ext>
-            </a:extLst>
-          </p:cNvPr>
-          <p:cNvPicPr>
-            <a:picLocks noChangeAspect="1"/>
-          </p:cNvPicPr>
-          <p:nvPr/>
-        </p:nvPicPr>
-        <p:blipFill>
-          <a:blip r:embed="rId2"/>
-          <a:srcRect l="6724" t="28966" r="7635" b="33064"/>
-          <a:stretch>
-            <a:fillRect/>
-          </a:stretch>
-        </p:blipFill>
-        <p:spPr>
-          <a:xfrm>
-            <a:off x="4698380" y="1911402"/>
-            <a:ext cx="2795239" cy="429169"/>
-          </a:xfrm>
-          <a:prstGeom prst="rect">
-            <a:avLst/>
-          </a:prstGeom>
-        </p:spPr>
-      </p:pic>
-      <p:cxnSp>
-        <p:nvCxnSpPr>
-          <p:cNvPr id="4" name="Straight Arrow Connector 3">
-            <a:extLst>
-              <a:ext uri="{FF2B5EF4-FFF2-40B4-BE49-F238E27FC236}">
-                <a16:creationId xmlns:a16="http://schemas.microsoft.com/office/drawing/2014/main" id="{DCA7A5DE-84D6-7B99-65F5-B173EDB935CB}"/>
-              </a:ext>
-            </a:extLst>
-          </p:cNvPr>
-          <p:cNvCxnSpPr>
-            <a:stCxn id="2" idx="2"/>
-          </p:cNvCxnSpPr>
-          <p:nvPr/>
-        </p:nvCxnSpPr>
-        <p:spPr>
-          <a:xfrm flipH="1">
-            <a:off x="6095999" y="2527431"/>
-            <a:ext cx="1" cy="474203"/>
-          </a:xfrm>
-          <a:prstGeom prst="straightConnector1">
-            <a:avLst/>
-          </a:prstGeom>
-          <a:ln>
-            <a:tailEnd type="triangle"/>
-          </a:ln>
-        </p:spPr>
-        <p:style>
-          <a:lnRef idx="2">
-            <a:schemeClr val="dk1"/>
-          </a:lnRef>
-          <a:fillRef idx="0">
-            <a:schemeClr val="dk1"/>
-          </a:fillRef>
-          <a:effectRef idx="1">
-            <a:schemeClr val="dk1"/>
-          </a:effectRef>
-          <a:fontRef idx="minor">
-            <a:schemeClr val="tx1"/>
-          </a:fontRef>
-        </p:style>
-      </p:cxnSp>
-      <p:sp>
-        <p:nvSpPr>
-          <p:cNvPr id="5" name="Rounded Rectangle 4">
-            <a:extLst>
-              <a:ext uri="{FF2B5EF4-FFF2-40B4-BE49-F238E27FC236}">
-                <a16:creationId xmlns:a16="http://schemas.microsoft.com/office/drawing/2014/main" id="{78D4668A-A7A2-7E8C-010F-B20127AF1E37}"/>
-              </a:ext>
-            </a:extLst>
-          </p:cNvPr>
-          <p:cNvSpPr/>
-          <p:nvPr/>
-        </p:nvSpPr>
-        <p:spPr>
-          <a:xfrm>
-            <a:off x="4289502" y="3001634"/>
-            <a:ext cx="3612996" cy="802888"/>
-          </a:xfrm>
-          <a:prstGeom prst="roundRect">
-            <a:avLst/>
-          </a:prstGeom>
-          <a:solidFill>
-            <a:schemeClr val="bg2"/>
-          </a:solidFill>
-          <a:ln>
+            <a:ln>
+              <a:solidFill>
+                <a:schemeClr val="bg2"/>
+              </a:solidFill>
+            </a:ln>
+          </p:spPr>
+          <p:style>
+            <a:lnRef idx="2">
+              <a:schemeClr val="accent1">
+                <a:shade val="15000"/>
+              </a:schemeClr>
+            </a:lnRef>
+            <a:fillRef idx="1">
+              <a:schemeClr val="accent1"/>
+            </a:fillRef>
+            <a:effectRef idx="0">
+              <a:schemeClr val="accent1"/>
+            </a:effectRef>
+            <a:fontRef idx="minor">
+              <a:schemeClr val="lt1"/>
+            </a:fontRef>
+          </p:style>
+          <p:txBody>
+            <a:bodyPr rtlCol="0" anchor="ctr"/>
+            <a:lstStyle/>
+            <a:p>
+              <a:pPr algn="ctr"/>
+              <a:endParaRPr lang="en-US" dirty="0"/>
+            </a:p>
+          </p:txBody>
+        </p:sp>
+        <p:pic>
+          <p:nvPicPr>
+            <p:cNvPr id="3" name="Picture 2">
+              <a:extLst>
+                <a:ext uri="{FF2B5EF4-FFF2-40B4-BE49-F238E27FC236}">
+                  <a16:creationId xmlns:a16="http://schemas.microsoft.com/office/drawing/2014/main" id="{3DA09D05-66BA-2EAB-4EE0-D91C6DF698DB}"/>
+                </a:ext>
+              </a:extLst>
+            </p:cNvPr>
+            <p:cNvPicPr>
+              <a:picLocks noChangeAspect="1"/>
+            </p:cNvPicPr>
+            <p:nvPr/>
+          </p:nvPicPr>
+          <p:blipFill>
+            <a:blip r:embed="rId2"/>
+            <a:srcRect l="6724" t="28966" r="7635" b="33064"/>
+            <a:stretch>
+              <a:fillRect/>
+            </a:stretch>
+          </p:blipFill>
+          <p:spPr>
+            <a:xfrm>
+              <a:off x="4698380" y="1911402"/>
+              <a:ext cx="2795239" cy="429169"/>
+            </a:xfrm>
+            <a:prstGeom prst="rect">
+              <a:avLst/>
+            </a:prstGeom>
+          </p:spPr>
+        </p:pic>
+        <p:cxnSp>
+          <p:nvCxnSpPr>
+            <p:cNvPr id="4" name="Straight Arrow Connector 3">
+              <a:extLst>
+                <a:ext uri="{FF2B5EF4-FFF2-40B4-BE49-F238E27FC236}">
+                  <a16:creationId xmlns:a16="http://schemas.microsoft.com/office/drawing/2014/main" id="{DCA7A5DE-84D6-7B99-65F5-B173EDB935CB}"/>
+                </a:ext>
+              </a:extLst>
+            </p:cNvPr>
+            <p:cNvCxnSpPr>
+              <a:stCxn id="2" idx="2"/>
+            </p:cNvCxnSpPr>
+            <p:nvPr/>
+          </p:nvCxnSpPr>
+          <p:spPr>
+            <a:xfrm flipH="1">
+              <a:off x="6095999" y="2527431"/>
+              <a:ext cx="1" cy="474203"/>
+            </a:xfrm>
+            <a:prstGeom prst="straightConnector1">
+              <a:avLst/>
+            </a:prstGeom>
+            <a:ln>
+              <a:tailEnd type="triangle"/>
+            </a:ln>
+          </p:spPr>
+          <p:style>
+            <a:lnRef idx="2">
+              <a:schemeClr val="dk1"/>
+            </a:lnRef>
+            <a:fillRef idx="0">
+              <a:schemeClr val="dk1"/>
+            </a:fillRef>
+            <a:effectRef idx="1">
+              <a:schemeClr val="dk1"/>
+            </a:effectRef>
+            <a:fontRef idx="minor">
+              <a:schemeClr val="tx1"/>
+            </a:fontRef>
+          </p:style>
+        </p:cxnSp>
+        <p:sp>
+          <p:nvSpPr>
+            <p:cNvPr id="5" name="Rounded Rectangle 4">
+              <a:extLst>
+                <a:ext uri="{FF2B5EF4-FFF2-40B4-BE49-F238E27FC236}">
+                  <a16:creationId xmlns:a16="http://schemas.microsoft.com/office/drawing/2014/main" id="{78D4668A-A7A2-7E8C-010F-B20127AF1E37}"/>
+                </a:ext>
+              </a:extLst>
+            </p:cNvPr>
+            <p:cNvSpPr/>
+            <p:nvPr/>
+          </p:nvSpPr>
+          <p:spPr>
+            <a:xfrm>
+              <a:off x="4289502" y="3001634"/>
+              <a:ext cx="3612996" cy="802888"/>
+            </a:xfrm>
+            <a:prstGeom prst="roundRect">
+              <a:avLst/>
+            </a:prstGeom>
             <a:solidFill>
               <a:schemeClr val="bg2"/>
             </a:solidFill>
-          </a:ln>
-        </p:spPr>
-        <p:style>
-          <a:lnRef idx="2">
-            <a:schemeClr val="accent1">
-              <a:shade val="15000"/>
-            </a:schemeClr>
-          </a:lnRef>
-          <a:fillRef idx="1">
-            <a:schemeClr val="accent1"/>
-          </a:fillRef>
-          <a:effectRef idx="0">
-            <a:schemeClr val="accent1"/>
-          </a:effectRef>
-          <a:fontRef idx="minor">
-            <a:schemeClr val="lt1"/>
-          </a:fontRef>
-        </p:style>
-        <p:txBody>
-          <a:bodyPr rtlCol="0" anchor="ctr"/>
-          <a:lstStyle/>
-          <a:p>
-            <a:pPr algn="ctr"/>
-            <a:endParaRPr dirty="0"/>
-          </a:p>
-        </p:txBody>
-      </p:sp>
-      <mc:AlternateContent xmlns:mc="http://schemas.openxmlformats.org/markup-compatibility/2006" xmlns:a14="http://schemas.microsoft.com/office/drawing/2010/main">
-        <mc:Choice Requires="a14">
-          <p:sp>
-            <p:nvSpPr>
-              <p:cNvPr id="6" name="Oval 5">
-                <a:extLst>
-                  <a:ext uri="{FF2B5EF4-FFF2-40B4-BE49-F238E27FC236}">
-                    <a16:creationId xmlns:a16="http://schemas.microsoft.com/office/drawing/2014/main" id="{6A526B68-6273-71FF-FDEF-05453095179C}"/>
-                  </a:ext>
-                </a:extLst>
-              </p:cNvPr>
-              <p:cNvSpPr/>
-              <p:nvPr/>
-            </p:nvSpPr>
-            <p:spPr>
-              <a:xfrm>
-                <a:off x="4881667" y="3105452"/>
-                <a:ext cx="594000" cy="595252"/>
-              </a:xfrm>
-              <a:prstGeom prst="ellipse">
-                <a:avLst/>
-              </a:prstGeom>
+            <a:ln>
               <a:solidFill>
-                <a:schemeClr val="accent6">
-                  <a:lumMod val="40000"/>
-                  <a:lumOff val="60000"/>
-                </a:schemeClr>
+                <a:schemeClr val="bg2"/>
               </a:solidFill>
-              <a:ln>
+            </a:ln>
+          </p:spPr>
+          <p:style>
+            <a:lnRef idx="2">
+              <a:schemeClr val="accent1">
+                <a:shade val="15000"/>
+              </a:schemeClr>
+            </a:lnRef>
+            <a:fillRef idx="1">
+              <a:schemeClr val="accent1"/>
+            </a:fillRef>
+            <a:effectRef idx="0">
+              <a:schemeClr val="accent1"/>
+            </a:effectRef>
+            <a:fontRef idx="minor">
+              <a:schemeClr val="lt1"/>
+            </a:fontRef>
+          </p:style>
+          <p:txBody>
+            <a:bodyPr rtlCol="0" anchor="ctr"/>
+            <a:lstStyle/>
+            <a:p>
+              <a:pPr algn="ctr"/>
+              <a:endParaRPr dirty="0"/>
+            </a:p>
+          </p:txBody>
+        </p:sp>
+        <mc:AlternateContent xmlns:mc="http://schemas.openxmlformats.org/markup-compatibility/2006">
+          <mc:Choice xmlns:a14="http://schemas.microsoft.com/office/drawing/2010/main" Requires="a14">
+            <p:sp>
+              <p:nvSpPr>
+                <p:cNvPr id="6" name="Oval 5">
+                  <a:extLst>
+                    <a:ext uri="{FF2B5EF4-FFF2-40B4-BE49-F238E27FC236}">
+                      <a16:creationId xmlns:a16="http://schemas.microsoft.com/office/drawing/2014/main" id="{6A526B68-6273-71FF-FDEF-05453095179C}"/>
+                    </a:ext>
+                  </a:extLst>
+                </p:cNvPr>
+                <p:cNvSpPr/>
+                <p:nvPr/>
+              </p:nvSpPr>
+              <p:spPr>
+                <a:xfrm>
+                  <a:off x="4881667" y="3105452"/>
+                  <a:ext cx="594000" cy="595252"/>
+                </a:xfrm>
+                <a:prstGeom prst="ellipse">
+                  <a:avLst/>
+                </a:prstGeom>
                 <a:solidFill>
                   <a:schemeClr val="accent6">
                     <a:lumMod val="40000"/>
                     <a:lumOff val="60000"/>
                   </a:schemeClr>
                 </a:solidFill>
-              </a:ln>
-            </p:spPr>
-            <p:style>
-              <a:lnRef idx="2">
-                <a:schemeClr val="accent1">
-                  <a:shade val="15000"/>
-                </a:schemeClr>
-              </a:lnRef>
-              <a:fillRef idx="1">
-                <a:schemeClr val="accent1"/>
-              </a:fillRef>
-              <a:effectRef idx="0">
-                <a:schemeClr val="accent1"/>
-              </a:effectRef>
-              <a:fontRef idx="minor">
-                <a:schemeClr val="lt1"/>
-              </a:fontRef>
-            </p:style>
-            <p:txBody>
-              <a:bodyPr rtlCol="0" anchor="ctr"/>
-              <a:lstStyle/>
-              <a:p>
-                <a:pPr algn="ctr"/>
-                <a14:m>
-                  <m:oMathPara xmlns:m="http://schemas.openxmlformats.org/officeDocument/2006/math">
-                    <m:oMath>
-                      <m:sSubSup>
-                        <m:sSubSupPr>
-                          <m:ctrlPr>
-                            <a:rPr lang="en-US" b="0" i="1" smtClean="0">
-                              <a:solidFill>
-                                <a:schemeClr val="tx1"/>
-                              </a:solidFill>
-                              <a:latin typeface="Cambria Math" panose="02040503050406030204" pitchFamily="18" charset="0"/>
-                            </a:rPr>
-                          </m:ctrlPr>
-                        </m:sSubSupPr>
-                        <m:e>
-                          <m:r>
-                            <a:rPr lang="en-US" b="0" i="1" smtClean="0">
-                              <a:solidFill>
-                                <a:schemeClr val="tx1"/>
-                              </a:solidFill>
-                              <a:latin typeface="Cambria Math" panose="02040503050406030204" pitchFamily="18" charset="0"/>
-                            </a:rPr>
-                            <m:t>ℎ</m:t>
-                          </m:r>
-                        </m:e>
-                        <m:sub>
-                          <m:r>
-                            <a:rPr lang="en-US" b="0" i="1" smtClean="0">
-                              <a:solidFill>
-                                <a:schemeClr val="tx1"/>
-                              </a:solidFill>
-                              <a:latin typeface="Cambria Math" panose="02040503050406030204" pitchFamily="18" charset="0"/>
-                            </a:rPr>
-                            <m:t>𝑡</m:t>
-                          </m:r>
-                        </m:sub>
-                        <m:sup>
-                          <m:r>
-                            <a:rPr lang="en-US" b="0" i="1" smtClean="0">
-                              <a:solidFill>
-                                <a:schemeClr val="tx1"/>
-                              </a:solidFill>
-                              <a:latin typeface="Cambria Math" panose="02040503050406030204" pitchFamily="18" charset="0"/>
-                            </a:rPr>
-                            <m:t>(1)</m:t>
-                          </m:r>
-                        </m:sup>
-                      </m:sSubSup>
-                    </m:oMath>
-                  </m:oMathPara>
-                </a14:m>
-                <a:endParaRPr lang="en-US" dirty="0"/>
-              </a:p>
-            </p:txBody>
-          </p:sp>
-        </mc:Choice>
-        <mc:Fallback xmlns="">
-          <p:sp>
-            <p:nvSpPr>
-              <p:cNvPr id="6" name="Oval 5">
-                <a:extLst>
-                  <a:ext uri="{FF2B5EF4-FFF2-40B4-BE49-F238E27FC236}">
-                    <a16:creationId xmlns:a16="http://schemas.microsoft.com/office/drawing/2014/main" id="{6A526B68-6273-71FF-FDEF-05453095179C}"/>
-                  </a:ext>
-                </a:extLst>
-              </p:cNvPr>
-              <p:cNvSpPr>
-                <a:spLocks noRot="1" noChangeAspect="1" noMove="1" noResize="1" noEditPoints="1" noAdjustHandles="1" noChangeArrowheads="1" noChangeShapeType="1" noTextEdit="1"/>
-              </p:cNvSpPr>
-              <p:nvPr/>
-            </p:nvSpPr>
-            <p:spPr>
-              <a:xfrm>
-                <a:off x="4881667" y="3105452"/>
-                <a:ext cx="594000" cy="595252"/>
-              </a:xfrm>
-              <a:prstGeom prst="ellipse">
-                <a:avLst/>
-              </a:prstGeom>
-              <a:blipFill>
-                <a:blip r:embed="rId3"/>
-                <a:stretch>
-                  <a:fillRect/>
-                </a:stretch>
-              </a:blipFill>
-              <a:ln>
+                <a:ln>
+                  <a:solidFill>
+                    <a:schemeClr val="accent6">
+                      <a:lumMod val="40000"/>
+                      <a:lumOff val="60000"/>
+                    </a:schemeClr>
+                  </a:solidFill>
+                </a:ln>
+              </p:spPr>
+              <p:style>
+                <a:lnRef idx="2">
+                  <a:schemeClr val="accent1">
+                    <a:shade val="15000"/>
+                  </a:schemeClr>
+                </a:lnRef>
+                <a:fillRef idx="1">
+                  <a:schemeClr val="accent1"/>
+                </a:fillRef>
+                <a:effectRef idx="0">
+                  <a:schemeClr val="accent1"/>
+                </a:effectRef>
+                <a:fontRef idx="minor">
+                  <a:schemeClr val="lt1"/>
+                </a:fontRef>
+              </p:style>
+              <p:txBody>
+                <a:bodyPr rtlCol="0" anchor="ctr"/>
+                <a:lstStyle/>
+                <a:p>
+                  <a:pPr algn="ctr"/>
+                  <a14:m>
+                    <m:oMathPara xmlns:m="http://schemas.openxmlformats.org/officeDocument/2006/math">
+                      <m:oMath>
+                        <m:sSubSup>
+                          <m:sSubSupPr>
+                            <m:ctrlPr>
+                              <a:rPr lang="en-US" b="0" i="1" smtClean="0">
+                                <a:solidFill>
+                                  <a:schemeClr val="tx1"/>
+                                </a:solidFill>
+                                <a:latin typeface="Cambria Math" panose="02040503050406030204" pitchFamily="18" charset="0"/>
+                              </a:rPr>
+                            </m:ctrlPr>
+                          </m:sSubSupPr>
+                          <m:e>
+                            <m:r>
+                              <a:rPr lang="en-US" b="0" i="1" smtClean="0">
+                                <a:solidFill>
+                                  <a:schemeClr val="tx1"/>
+                                </a:solidFill>
+                                <a:latin typeface="Cambria Math" panose="02040503050406030204" pitchFamily="18" charset="0"/>
+                              </a:rPr>
+                              <m:t>ℎ</m:t>
+                            </m:r>
+                          </m:e>
+                          <m:sub>
+                            <m:r>
+                              <a:rPr lang="en-US" b="0" i="1" smtClean="0">
+                                <a:solidFill>
+                                  <a:schemeClr val="tx1"/>
+                                </a:solidFill>
+                                <a:latin typeface="Cambria Math" panose="02040503050406030204" pitchFamily="18" charset="0"/>
+                              </a:rPr>
+                              <m:t>𝑡</m:t>
+                            </m:r>
+                          </m:sub>
+                          <m:sup>
+                            <m:r>
+                              <a:rPr lang="en-US" b="0" i="1" smtClean="0">
+                                <a:solidFill>
+                                  <a:schemeClr val="tx1"/>
+                                </a:solidFill>
+                                <a:latin typeface="Cambria Math" panose="02040503050406030204" pitchFamily="18" charset="0"/>
+                              </a:rPr>
+                              <m:t>(1)</m:t>
+                            </m:r>
+                          </m:sup>
+                        </m:sSubSup>
+                      </m:oMath>
+                    </m:oMathPara>
+                  </a14:m>
+                  <a:endParaRPr lang="en-US" dirty="0"/>
+                </a:p>
+              </p:txBody>
+            </p:sp>
+          </mc:Choice>
+          <mc:Fallback>
+            <p:sp>
+              <p:nvSpPr>
+                <p:cNvPr id="6" name="Oval 5">
+                  <a:extLst>
+                    <a:ext uri="{FF2B5EF4-FFF2-40B4-BE49-F238E27FC236}">
+                      <a16:creationId xmlns:a16="http://schemas.microsoft.com/office/drawing/2014/main" id="{6A526B68-6273-71FF-FDEF-05453095179C}"/>
+                    </a:ext>
+                  </a:extLst>
+                </p:cNvPr>
+                <p:cNvSpPr>
+                  <a:spLocks noRot="1" noChangeAspect="1" noMove="1" noResize="1" noEditPoints="1" noAdjustHandles="1" noChangeArrowheads="1" noChangeShapeType="1" noTextEdit="1"/>
+                </p:cNvSpPr>
+                <p:nvPr/>
+              </p:nvSpPr>
+              <p:spPr>
+                <a:xfrm>
+                  <a:off x="4881667" y="3105452"/>
+                  <a:ext cx="594000" cy="595252"/>
+                </a:xfrm>
+                <a:prstGeom prst="ellipse">
+                  <a:avLst/>
+                </a:prstGeom>
+                <a:blipFill>
+                  <a:blip r:embed="rId3"/>
+                  <a:stretch>
+                    <a:fillRect/>
+                  </a:stretch>
+                </a:blipFill>
+                <a:ln>
+                  <a:solidFill>
+                    <a:schemeClr val="accent6">
+                      <a:lumMod val="40000"/>
+                      <a:lumOff val="60000"/>
+                    </a:schemeClr>
+                  </a:solidFill>
+                </a:ln>
+              </p:spPr>
+              <p:txBody>
+                <a:bodyPr/>
+                <a:lstStyle/>
+                <a:p>
+                  <a:r>
+                    <a:rPr lang="en-US">
+                      <a:noFill/>
+                    </a:rPr>
+                    <a:t> </a:t>
+                  </a:r>
+                </a:p>
+              </p:txBody>
+            </p:sp>
+          </mc:Fallback>
+        </mc:AlternateContent>
+        <mc:AlternateContent xmlns:mc="http://schemas.openxmlformats.org/markup-compatibility/2006">
+          <mc:Choice xmlns:a14="http://schemas.microsoft.com/office/drawing/2010/main" Requires="a14">
+            <p:sp>
+              <p:nvSpPr>
+                <p:cNvPr id="7" name="Oval 6">
+                  <a:extLst>
+                    <a:ext uri="{FF2B5EF4-FFF2-40B4-BE49-F238E27FC236}">
+                      <a16:creationId xmlns:a16="http://schemas.microsoft.com/office/drawing/2014/main" id="{B01763EB-9923-B7E8-A154-A4979D845608}"/>
+                    </a:ext>
+                  </a:extLst>
+                </p:cNvPr>
+                <p:cNvSpPr/>
+                <p:nvPr/>
+              </p:nvSpPr>
+              <p:spPr>
+                <a:xfrm>
+                  <a:off x="6624352" y="3105452"/>
+                  <a:ext cx="594000" cy="595252"/>
+                </a:xfrm>
+                <a:prstGeom prst="ellipse">
+                  <a:avLst/>
+                </a:prstGeom>
                 <a:solidFill>
                   <a:schemeClr val="accent6">
                     <a:lumMod val="40000"/>
                     <a:lumOff val="60000"/>
                   </a:schemeClr>
                 </a:solidFill>
-              </a:ln>
-            </p:spPr>
-            <p:txBody>
-              <a:bodyPr/>
-              <a:lstStyle/>
-              <a:p>
-                <a:r>
-                  <a:rPr lang="en-US">
-                    <a:noFill/>
-                  </a:rPr>
-                  <a:t> </a:t>
-                </a:r>
-              </a:p>
-            </p:txBody>
-          </p:sp>
-        </mc:Fallback>
-      </mc:AlternateContent>
-      <mc:AlternateContent xmlns:mc="http://schemas.openxmlformats.org/markup-compatibility/2006" xmlns:a14="http://schemas.microsoft.com/office/drawing/2010/main">
-        <mc:Choice Requires="a14">
-          <p:sp>
-            <p:nvSpPr>
-              <p:cNvPr id="7" name="Oval 6">
-                <a:extLst>
-                  <a:ext uri="{FF2B5EF4-FFF2-40B4-BE49-F238E27FC236}">
-                    <a16:creationId xmlns:a16="http://schemas.microsoft.com/office/drawing/2014/main" id="{B01763EB-9923-B7E8-A154-A4979D845608}"/>
-                  </a:ext>
-                </a:extLst>
-              </p:cNvPr>
-              <p:cNvSpPr/>
-              <p:nvPr/>
-            </p:nvSpPr>
-            <p:spPr>
-              <a:xfrm>
-                <a:off x="6624352" y="3105452"/>
-                <a:ext cx="594000" cy="595252"/>
-              </a:xfrm>
-              <a:prstGeom prst="ellipse">
-                <a:avLst/>
-              </a:prstGeom>
-              <a:solidFill>
-                <a:schemeClr val="accent6">
-                  <a:lumMod val="40000"/>
-                  <a:lumOff val="60000"/>
-                </a:schemeClr>
-              </a:solidFill>
-              <a:ln>
-                <a:solidFill>
-                  <a:schemeClr val="accent6">
-                    <a:lumMod val="40000"/>
-                    <a:lumOff val="60000"/>
+                <a:ln>
+                  <a:solidFill>
+                    <a:schemeClr val="accent6">
+                      <a:lumMod val="40000"/>
+                      <a:lumOff val="60000"/>
+                    </a:schemeClr>
+                  </a:solidFill>
+                </a:ln>
+              </p:spPr>
+              <p:style>
+                <a:lnRef idx="2">
+                  <a:schemeClr val="accent1">
+                    <a:shade val="15000"/>
                   </a:schemeClr>
-                </a:solidFill>
-              </a:ln>
-            </p:spPr>
-            <p:style>
-              <a:lnRef idx="2">
-                <a:schemeClr val="accent1">
-                  <a:shade val="15000"/>
-                </a:schemeClr>
-              </a:lnRef>
-              <a:fillRef idx="1">
-                <a:schemeClr val="accent1"/>
-              </a:fillRef>
-              <a:effectRef idx="0">
-                <a:schemeClr val="accent1"/>
-              </a:effectRef>
-              <a:fontRef idx="minor">
-                <a:schemeClr val="lt1"/>
-              </a:fontRef>
-            </p:style>
-            <p:txBody>
-              <a:bodyPr rtlCol="0" anchor="ctr"/>
-              <a:lstStyle/>
-              <a:p>
-                <a:pPr algn="ctr"/>
-                <a14:m>
-                  <m:oMathPara xmlns:m="http://schemas.openxmlformats.org/officeDocument/2006/math">
-                    <m:oMath>
-                      <m:sSubSup>
-                        <m:sSubSupPr>
-                          <m:ctrlPr>
-                            <a:rPr lang="en-US" b="0" i="1" smtClean="0">
-                              <a:solidFill>
-                                <a:schemeClr val="tx1"/>
-                              </a:solidFill>
-                              <a:latin typeface="Cambria Math" panose="02040503050406030204" pitchFamily="18" charset="0"/>
-                            </a:rPr>
-                          </m:ctrlPr>
-                        </m:sSubSupPr>
-                        <m:e>
-                          <m:r>
-                            <a:rPr lang="en-US" b="0" i="1" smtClean="0">
-                              <a:solidFill>
-                                <a:schemeClr val="tx1"/>
-                              </a:solidFill>
-                              <a:latin typeface="Cambria Math" panose="02040503050406030204" pitchFamily="18" charset="0"/>
-                            </a:rPr>
-                            <m:t>ℎ</m:t>
-                          </m:r>
-                        </m:e>
-                        <m:sub>
-                          <m:r>
-                            <a:rPr lang="en-US" b="0" i="1" smtClean="0">
-                              <a:solidFill>
-                                <a:schemeClr val="tx1"/>
-                              </a:solidFill>
-                              <a:latin typeface="Cambria Math" panose="02040503050406030204" pitchFamily="18" charset="0"/>
-                            </a:rPr>
-                            <m:t>𝑡</m:t>
-                          </m:r>
-                        </m:sub>
-                        <m:sup>
-                          <m:r>
-                            <a:rPr lang="en-US" b="0" i="1" smtClean="0">
-                              <a:solidFill>
-                                <a:schemeClr val="tx1"/>
-                              </a:solidFill>
-                              <a:latin typeface="Cambria Math" panose="02040503050406030204" pitchFamily="18" charset="0"/>
-                            </a:rPr>
-                            <m:t>(2)</m:t>
-                          </m:r>
-                        </m:sup>
-                      </m:sSubSup>
-                    </m:oMath>
-                  </m:oMathPara>
-                </a14:m>
-                <a:endParaRPr lang="en-US" dirty="0"/>
-              </a:p>
-            </p:txBody>
-          </p:sp>
-        </mc:Choice>
-        <mc:Fallback xmlns="">
-          <p:sp>
-            <p:nvSpPr>
-              <p:cNvPr id="7" name="Oval 6">
-                <a:extLst>
-                  <a:ext uri="{FF2B5EF4-FFF2-40B4-BE49-F238E27FC236}">
-                    <a16:creationId xmlns:a16="http://schemas.microsoft.com/office/drawing/2014/main" id="{B01763EB-9923-B7E8-A154-A4979D845608}"/>
-                  </a:ext>
-                </a:extLst>
-              </p:cNvPr>
-              <p:cNvSpPr>
-                <a:spLocks noRot="1" noChangeAspect="1" noMove="1" noResize="1" noEditPoints="1" noAdjustHandles="1" noChangeArrowheads="1" noChangeShapeType="1" noTextEdit="1"/>
-              </p:cNvSpPr>
-              <p:nvPr/>
-            </p:nvSpPr>
-            <p:spPr>
-              <a:xfrm>
-                <a:off x="6624352" y="3105452"/>
-                <a:ext cx="594000" cy="595252"/>
-              </a:xfrm>
-              <a:prstGeom prst="ellipse">
-                <a:avLst/>
-              </a:prstGeom>
-              <a:blipFill>
-                <a:blip r:embed="rId4"/>
-                <a:stretch>
-                  <a:fillRect/>
-                </a:stretch>
-              </a:blipFill>
-              <a:ln>
-                <a:solidFill>
-                  <a:schemeClr val="accent6">
-                    <a:lumMod val="40000"/>
-                    <a:lumOff val="60000"/>
-                  </a:schemeClr>
-                </a:solidFill>
-              </a:ln>
-            </p:spPr>
-            <p:txBody>
-              <a:bodyPr/>
-              <a:lstStyle/>
-              <a:p>
-                <a:r>
-                  <a:rPr lang="en-US">
-                    <a:noFill/>
-                  </a:rPr>
-                  <a:t> </a:t>
-                </a:r>
-              </a:p>
-            </p:txBody>
-          </p:sp>
-        </mc:Fallback>
-      </mc:AlternateContent>
-      <p:cxnSp>
-        <p:nvCxnSpPr>
-          <p:cNvPr id="8" name="Straight Arrow Connector 7">
-            <a:extLst>
-              <a:ext uri="{FF2B5EF4-FFF2-40B4-BE49-F238E27FC236}">
-                <a16:creationId xmlns:a16="http://schemas.microsoft.com/office/drawing/2014/main" id="{481D860F-06AF-FEAA-6DA8-47994D69C761}"/>
-              </a:ext>
-            </a:extLst>
-          </p:cNvPr>
-          <p:cNvCxnSpPr/>
-          <p:nvPr/>
-        </p:nvCxnSpPr>
-        <p:spPr>
-          <a:xfrm flipH="1">
-            <a:off x="6095998" y="3804522"/>
-            <a:ext cx="1" cy="474203"/>
-          </a:xfrm>
-          <a:prstGeom prst="straightConnector1">
-            <a:avLst/>
-          </a:prstGeom>
-          <a:ln>
-            <a:tailEnd type="triangle"/>
-          </a:ln>
-        </p:spPr>
-        <p:style>
-          <a:lnRef idx="2">
-            <a:schemeClr val="dk1"/>
-          </a:lnRef>
-          <a:fillRef idx="0">
-            <a:schemeClr val="dk1"/>
-          </a:fillRef>
-          <a:effectRef idx="1">
-            <a:schemeClr val="dk1"/>
-          </a:effectRef>
-          <a:fontRef idx="minor">
-            <a:schemeClr val="tx1"/>
-          </a:fontRef>
-        </p:style>
-      </p:cxnSp>
-      <p:sp>
-        <p:nvSpPr>
-          <p:cNvPr id="9" name="Rounded Rectangle 8">
-            <a:extLst>
-              <a:ext uri="{FF2B5EF4-FFF2-40B4-BE49-F238E27FC236}">
-                <a16:creationId xmlns:a16="http://schemas.microsoft.com/office/drawing/2014/main" id="{92F85D4A-A729-A6EF-05F2-469366233CE2}"/>
-              </a:ext>
-            </a:extLst>
-          </p:cNvPr>
-          <p:cNvSpPr/>
-          <p:nvPr/>
-        </p:nvSpPr>
-        <p:spPr>
-          <a:xfrm>
-            <a:off x="4289500" y="4278725"/>
-            <a:ext cx="3612996" cy="802888"/>
-          </a:xfrm>
-          <a:prstGeom prst="roundRect">
-            <a:avLst/>
-          </a:prstGeom>
-          <a:solidFill>
-            <a:schemeClr val="bg2"/>
-          </a:solidFill>
-          <a:ln>
+                </a:lnRef>
+                <a:fillRef idx="1">
+                  <a:schemeClr val="accent1"/>
+                </a:fillRef>
+                <a:effectRef idx="0">
+                  <a:schemeClr val="accent1"/>
+                </a:effectRef>
+                <a:fontRef idx="minor">
+                  <a:schemeClr val="lt1"/>
+                </a:fontRef>
+              </p:style>
+              <p:txBody>
+                <a:bodyPr rtlCol="0" anchor="ctr"/>
+                <a:lstStyle/>
+                <a:p>
+                  <a:pPr algn="ctr"/>
+                  <a14:m>
+                    <m:oMathPara xmlns:m="http://schemas.openxmlformats.org/officeDocument/2006/math">
+                      <m:oMath>
+                        <m:sSubSup>
+                          <m:sSubSupPr>
+                            <m:ctrlPr>
+                              <a:rPr lang="en-US" b="0" i="1" smtClean="0">
+                                <a:solidFill>
+                                  <a:schemeClr val="tx1"/>
+                                </a:solidFill>
+                                <a:latin typeface="Cambria Math" panose="02040503050406030204" pitchFamily="18" charset="0"/>
+                              </a:rPr>
+                            </m:ctrlPr>
+                          </m:sSubSupPr>
+                          <m:e>
+                            <m:r>
+                              <a:rPr lang="en-US" b="0" i="1" smtClean="0">
+                                <a:solidFill>
+                                  <a:schemeClr val="tx1"/>
+                                </a:solidFill>
+                                <a:latin typeface="Cambria Math" panose="02040503050406030204" pitchFamily="18" charset="0"/>
+                              </a:rPr>
+                              <m:t>ℎ</m:t>
+                            </m:r>
+                          </m:e>
+                          <m:sub>
+                            <m:r>
+                              <a:rPr lang="en-US" b="0" i="1" smtClean="0">
+                                <a:solidFill>
+                                  <a:schemeClr val="tx1"/>
+                                </a:solidFill>
+                                <a:latin typeface="Cambria Math" panose="02040503050406030204" pitchFamily="18" charset="0"/>
+                              </a:rPr>
+                              <m:t>𝑡</m:t>
+                            </m:r>
+                          </m:sub>
+                          <m:sup>
+                            <m:r>
+                              <a:rPr lang="en-US" b="0" i="1" smtClean="0">
+                                <a:solidFill>
+                                  <a:schemeClr val="tx1"/>
+                                </a:solidFill>
+                                <a:latin typeface="Cambria Math" panose="02040503050406030204" pitchFamily="18" charset="0"/>
+                              </a:rPr>
+                              <m:t>(2)</m:t>
+                            </m:r>
+                          </m:sup>
+                        </m:sSubSup>
+                      </m:oMath>
+                    </m:oMathPara>
+                  </a14:m>
+                  <a:endParaRPr lang="en-US" dirty="0"/>
+                </a:p>
+              </p:txBody>
+            </p:sp>
+          </mc:Choice>
+          <mc:Fallback>
+            <p:sp>
+              <p:nvSpPr>
+                <p:cNvPr id="7" name="Oval 6">
+                  <a:extLst>
+                    <a:ext uri="{FF2B5EF4-FFF2-40B4-BE49-F238E27FC236}">
+                      <a16:creationId xmlns:a16="http://schemas.microsoft.com/office/drawing/2014/main" id="{B01763EB-9923-B7E8-A154-A4979D845608}"/>
+                    </a:ext>
+                  </a:extLst>
+                </p:cNvPr>
+                <p:cNvSpPr>
+                  <a:spLocks noRot="1" noChangeAspect="1" noMove="1" noResize="1" noEditPoints="1" noAdjustHandles="1" noChangeArrowheads="1" noChangeShapeType="1" noTextEdit="1"/>
+                </p:cNvSpPr>
+                <p:nvPr/>
+              </p:nvSpPr>
+              <p:spPr>
+                <a:xfrm>
+                  <a:off x="6624352" y="3105452"/>
+                  <a:ext cx="594000" cy="595252"/>
+                </a:xfrm>
+                <a:prstGeom prst="ellipse">
+                  <a:avLst/>
+                </a:prstGeom>
+                <a:blipFill>
+                  <a:blip r:embed="rId4"/>
+                  <a:stretch>
+                    <a:fillRect/>
+                  </a:stretch>
+                </a:blipFill>
+                <a:ln>
+                  <a:solidFill>
+                    <a:schemeClr val="accent6">
+                      <a:lumMod val="40000"/>
+                      <a:lumOff val="60000"/>
+                    </a:schemeClr>
+                  </a:solidFill>
+                </a:ln>
+              </p:spPr>
+              <p:txBody>
+                <a:bodyPr/>
+                <a:lstStyle/>
+                <a:p>
+                  <a:r>
+                    <a:rPr lang="en-US">
+                      <a:noFill/>
+                    </a:rPr>
+                    <a:t> </a:t>
+                  </a:r>
+                </a:p>
+              </p:txBody>
+            </p:sp>
+          </mc:Fallback>
+        </mc:AlternateContent>
+        <p:cxnSp>
+          <p:nvCxnSpPr>
+            <p:cNvPr id="8" name="Straight Arrow Connector 7">
+              <a:extLst>
+                <a:ext uri="{FF2B5EF4-FFF2-40B4-BE49-F238E27FC236}">
+                  <a16:creationId xmlns:a16="http://schemas.microsoft.com/office/drawing/2014/main" id="{481D860F-06AF-FEAA-6DA8-47994D69C761}"/>
+                </a:ext>
+              </a:extLst>
+            </p:cNvPr>
+            <p:cNvCxnSpPr/>
+            <p:nvPr/>
+          </p:nvCxnSpPr>
+          <p:spPr>
+            <a:xfrm flipH="1">
+              <a:off x="6095998" y="3804522"/>
+              <a:ext cx="1" cy="474203"/>
+            </a:xfrm>
+            <a:prstGeom prst="straightConnector1">
+              <a:avLst/>
+            </a:prstGeom>
+            <a:ln>
+              <a:tailEnd type="triangle"/>
+            </a:ln>
+          </p:spPr>
+          <p:style>
+            <a:lnRef idx="2">
+              <a:schemeClr val="dk1"/>
+            </a:lnRef>
+            <a:fillRef idx="0">
+              <a:schemeClr val="dk1"/>
+            </a:fillRef>
+            <a:effectRef idx="1">
+              <a:schemeClr val="dk1"/>
+            </a:effectRef>
+            <a:fontRef idx="minor">
+              <a:schemeClr val="tx1"/>
+            </a:fontRef>
+          </p:style>
+        </p:cxnSp>
+        <p:sp>
+          <p:nvSpPr>
+            <p:cNvPr id="9" name="Rounded Rectangle 8">
+              <a:extLst>
+                <a:ext uri="{FF2B5EF4-FFF2-40B4-BE49-F238E27FC236}">
+                  <a16:creationId xmlns:a16="http://schemas.microsoft.com/office/drawing/2014/main" id="{92F85D4A-A729-A6EF-05F2-469366233CE2}"/>
+                </a:ext>
+              </a:extLst>
+            </p:cNvPr>
+            <p:cNvSpPr/>
+            <p:nvPr/>
+          </p:nvSpPr>
+          <p:spPr>
+            <a:xfrm>
+              <a:off x="4289500" y="4278725"/>
+              <a:ext cx="3612996" cy="802888"/>
+            </a:xfrm>
+            <a:prstGeom prst="roundRect">
+              <a:avLst/>
+            </a:prstGeom>
             <a:solidFill>
               <a:schemeClr val="bg2"/>
             </a:solidFill>
-          </a:ln>
-        </p:spPr>
-        <p:style>
-          <a:lnRef idx="2">
-            <a:schemeClr val="accent1">
-              <a:shade val="15000"/>
-            </a:schemeClr>
-          </a:lnRef>
-          <a:fillRef idx="1">
-            <a:schemeClr val="accent1"/>
-          </a:fillRef>
-          <a:effectRef idx="0">
-            <a:schemeClr val="accent1"/>
-          </a:effectRef>
-          <a:fontRef idx="minor">
-            <a:schemeClr val="lt1"/>
-          </a:fontRef>
-        </p:style>
-        <p:txBody>
-          <a:bodyPr rtlCol="0" anchor="ctr"/>
-          <a:lstStyle/>
-          <a:p>
-            <a:pPr algn="ctr"/>
-            <a:endParaRPr/>
-          </a:p>
-        </p:txBody>
-      </p:sp>
-      <mc:AlternateContent xmlns:mc="http://schemas.openxmlformats.org/markup-compatibility/2006" xmlns:a14="http://schemas.microsoft.com/office/drawing/2010/main">
-        <mc:Choice Requires="a14">
-          <p:sp>
-            <p:nvSpPr>
-              <p:cNvPr id="10" name="Rounded Rectangle 9">
-                <a:extLst>
-                  <a:ext uri="{FF2B5EF4-FFF2-40B4-BE49-F238E27FC236}">
-                    <a16:creationId xmlns:a16="http://schemas.microsoft.com/office/drawing/2014/main" id="{6404AE7E-EDBA-2D87-56A7-EB7B9118A568}"/>
-                  </a:ext>
-                </a:extLst>
-              </p:cNvPr>
-              <p:cNvSpPr/>
-              <p:nvPr/>
-            </p:nvSpPr>
-            <p:spPr>
-              <a:xfrm>
-                <a:off x="4414869" y="4447266"/>
-                <a:ext cx="1060798" cy="453239"/>
-              </a:xfrm>
-              <a:prstGeom prst="roundRect">
-                <a:avLst/>
-              </a:prstGeom>
+            <a:ln>
               <a:solidFill>
-                <a:srgbClr val="B3B3FF"/>
+                <a:schemeClr val="bg2"/>
               </a:solidFill>
-              <a:ln>
+            </a:ln>
+          </p:spPr>
+          <p:style>
+            <a:lnRef idx="2">
+              <a:schemeClr val="accent1">
+                <a:shade val="15000"/>
+              </a:schemeClr>
+            </a:lnRef>
+            <a:fillRef idx="1">
+              <a:schemeClr val="accent1"/>
+            </a:fillRef>
+            <a:effectRef idx="0">
+              <a:schemeClr val="accent1"/>
+            </a:effectRef>
+            <a:fontRef idx="minor">
+              <a:schemeClr val="lt1"/>
+            </a:fontRef>
+          </p:style>
+          <p:txBody>
+            <a:bodyPr rtlCol="0" anchor="ctr"/>
+            <a:lstStyle/>
+            <a:p>
+              <a:pPr algn="ctr"/>
+              <a:endParaRPr/>
+            </a:p>
+          </p:txBody>
+        </p:sp>
+        <mc:AlternateContent xmlns:mc="http://schemas.openxmlformats.org/markup-compatibility/2006">
+          <mc:Choice xmlns:a14="http://schemas.microsoft.com/office/drawing/2010/main" Requires="a14">
+            <p:sp>
+              <p:nvSpPr>
+                <p:cNvPr id="10" name="Rounded Rectangle 9">
+                  <a:extLst>
+                    <a:ext uri="{FF2B5EF4-FFF2-40B4-BE49-F238E27FC236}">
+                      <a16:creationId xmlns:a16="http://schemas.microsoft.com/office/drawing/2014/main" id="{6404AE7E-EDBA-2D87-56A7-EB7B9118A568}"/>
+                    </a:ext>
+                  </a:extLst>
+                </p:cNvPr>
+                <p:cNvSpPr/>
+                <p:nvPr/>
+              </p:nvSpPr>
+              <p:spPr>
+                <a:xfrm>
+                  <a:off x="4414869" y="4447266"/>
+                  <a:ext cx="1060798" cy="453239"/>
+                </a:xfrm>
+                <a:prstGeom prst="roundRect">
+                  <a:avLst/>
+                </a:prstGeom>
                 <a:solidFill>
                   <a:srgbClr val="B3B3FF"/>
                 </a:solidFill>
-              </a:ln>
-            </p:spPr>
-            <p:style>
-              <a:lnRef idx="2">
-                <a:schemeClr val="accent1">
-                  <a:shade val="15000"/>
-                </a:schemeClr>
-              </a:lnRef>
-              <a:fillRef idx="1">
-                <a:schemeClr val="accent1"/>
-              </a:fillRef>
-              <a:effectRef idx="0">
-                <a:schemeClr val="accent1"/>
-              </a:effectRef>
-              <a:fontRef idx="minor">
-                <a:schemeClr val="lt1"/>
-              </a:fontRef>
-            </p:style>
-            <p:txBody>
-              <a:bodyPr rtlCol="0" anchor="ctr"/>
-              <a:lstStyle/>
-              <a:p>
-                <a:pPr algn="ctr"/>
-                <a14:m>
-                  <m:oMathPara xmlns:m="http://schemas.openxmlformats.org/officeDocument/2006/math">
-                    <m:oMath>
-                      <m:r>
-                        <a:rPr lang="en-US" sz="1400" i="1" smtClean="0">
-                          <a:solidFill>
-                            <a:schemeClr val="tx1"/>
-                          </a:solidFill>
-                          <a:latin typeface="Cambria Math" panose="02040503050406030204" pitchFamily="18" charset="0"/>
-                        </a:rPr>
-                        <m:t>𝑃</m:t>
-                      </m:r>
-                      <m:d>
-                        <m:dPr>
-                          <m:ctrlPr>
-                            <a:rPr lang="en-US" sz="1400" i="1">
-                              <a:solidFill>
-                                <a:schemeClr val="tx1"/>
-                              </a:solidFill>
-                              <a:latin typeface="Cambria Math" panose="02040503050406030204" pitchFamily="18" charset="0"/>
-                            </a:rPr>
-                          </m:ctrlPr>
-                        </m:dPr>
-                        <m:e>
-                          <m:r>
-                            <a:rPr lang="en-US" sz="1400" i="1">
-                              <a:solidFill>
-                                <a:schemeClr val="tx1"/>
-                              </a:solidFill>
-                              <a:latin typeface="Cambria Math" panose="02040503050406030204" pitchFamily="18" charset="0"/>
-                            </a:rPr>
-                            <m:t>𝑐ℎ𝑜𝑜𝑠𝑒</m:t>
-                          </m:r>
-                          <m:r>
-                            <a:rPr lang="en-US" sz="1400" i="1">
-                              <a:solidFill>
-                                <a:schemeClr val="tx1"/>
-                              </a:solidFill>
-                              <a:latin typeface="Cambria Math" panose="02040503050406030204" pitchFamily="18" charset="0"/>
-                            </a:rPr>
-                            <m:t> </m:t>
-                          </m:r>
-                          <m:r>
-                            <a:rPr lang="en-US" sz="1400" i="1">
-                              <a:solidFill>
-                                <a:schemeClr val="tx1"/>
-                              </a:solidFill>
-                              <a:latin typeface="Cambria Math" panose="02040503050406030204" pitchFamily="18" charset="0"/>
-                            </a:rPr>
-                            <m:t>𝐴</m:t>
-                          </m:r>
-                        </m:e>
-                      </m:d>
-                    </m:oMath>
-                  </m:oMathPara>
-                </a14:m>
-                <a:endParaRPr lang="en-US" sz="1400" dirty="0">
+                <a:ln>
                   <a:solidFill>
-                    <a:schemeClr val="tx1"/>
+                    <a:srgbClr val="B3B3FF"/>
                   </a:solidFill>
-                </a:endParaRPr>
-              </a:p>
-            </p:txBody>
-          </p:sp>
-        </mc:Choice>
-        <mc:Fallback xmlns="">
-          <p:sp>
-            <p:nvSpPr>
-              <p:cNvPr id="10" name="Rounded Rectangle 9">
-                <a:extLst>
-                  <a:ext uri="{FF2B5EF4-FFF2-40B4-BE49-F238E27FC236}">
-                    <a16:creationId xmlns:a16="http://schemas.microsoft.com/office/drawing/2014/main" id="{6404AE7E-EDBA-2D87-56A7-EB7B9118A568}"/>
-                  </a:ext>
-                </a:extLst>
-              </p:cNvPr>
-              <p:cNvSpPr>
-                <a:spLocks noRot="1" noChangeAspect="1" noMove="1" noResize="1" noEditPoints="1" noAdjustHandles="1" noChangeArrowheads="1" noChangeShapeType="1" noTextEdit="1"/>
-              </p:cNvSpPr>
-              <p:nvPr/>
-            </p:nvSpPr>
-            <p:spPr>
-              <a:xfrm>
-                <a:off x="4414869" y="4447266"/>
-                <a:ext cx="1060798" cy="453239"/>
-              </a:xfrm>
-              <a:prstGeom prst="roundRect">
-                <a:avLst/>
-              </a:prstGeom>
-              <a:blipFill>
-                <a:blip r:embed="rId5"/>
-                <a:stretch>
-                  <a:fillRect l="-2326"/>
-                </a:stretch>
-              </a:blipFill>
-              <a:ln>
-                <a:solidFill>
-                  <a:srgbClr val="B3B3FF"/>
-                </a:solidFill>
-              </a:ln>
-            </p:spPr>
-            <p:txBody>
-              <a:bodyPr/>
-              <a:lstStyle/>
-              <a:p>
-                <a:r>
-                  <a:rPr lang="en-US">
-                    <a:noFill/>
-                  </a:rPr>
-                  <a:t> </a:t>
-                </a:r>
-              </a:p>
-            </p:txBody>
-          </p:sp>
-        </mc:Fallback>
-      </mc:AlternateContent>
-      <mc:AlternateContent xmlns:mc="http://schemas.openxmlformats.org/markup-compatibility/2006" xmlns:a14="http://schemas.microsoft.com/office/drawing/2010/main">
-        <mc:Choice Requires="a14">
-          <p:sp>
-            <p:nvSpPr>
-              <p:cNvPr id="11" name="Rounded Rectangle 10">
-                <a:extLst>
-                  <a:ext uri="{FF2B5EF4-FFF2-40B4-BE49-F238E27FC236}">
-                    <a16:creationId xmlns:a16="http://schemas.microsoft.com/office/drawing/2014/main" id="{FB2BE54A-EC8A-F02B-28D4-9552E37C1976}"/>
-                  </a:ext>
-                </a:extLst>
-              </p:cNvPr>
-              <p:cNvSpPr/>
-              <p:nvPr/>
-            </p:nvSpPr>
-            <p:spPr>
-              <a:xfrm>
-                <a:off x="5601036" y="4447266"/>
-                <a:ext cx="1060798" cy="453239"/>
-              </a:xfrm>
-              <a:prstGeom prst="roundRect">
-                <a:avLst/>
-              </a:prstGeom>
-              <a:solidFill>
-                <a:srgbClr val="FFB3B3"/>
-              </a:solidFill>
-              <a:ln>
+                </a:ln>
+              </p:spPr>
+              <p:style>
+                <a:lnRef idx="2">
+                  <a:schemeClr val="accent1">
+                    <a:shade val="15000"/>
+                  </a:schemeClr>
+                </a:lnRef>
+                <a:fillRef idx="1">
+                  <a:schemeClr val="accent1"/>
+                </a:fillRef>
+                <a:effectRef idx="0">
+                  <a:schemeClr val="accent1"/>
+                </a:effectRef>
+                <a:fontRef idx="minor">
+                  <a:schemeClr val="lt1"/>
+                </a:fontRef>
+              </p:style>
+              <p:txBody>
+                <a:bodyPr rtlCol="0" anchor="ctr"/>
+                <a:lstStyle/>
+                <a:p>
+                  <a:pPr algn="ctr"/>
+                  <a14:m>
+                    <m:oMathPara xmlns:m="http://schemas.openxmlformats.org/officeDocument/2006/math">
+                      <m:oMath>
+                        <m:r>
+                          <a:rPr lang="en-US" sz="1400" i="1" smtClean="0">
+                            <a:solidFill>
+                              <a:schemeClr val="tx1"/>
+                            </a:solidFill>
+                            <a:latin typeface="Cambria Math" panose="02040503050406030204" pitchFamily="18" charset="0"/>
+                          </a:rPr>
+                          <m:t>𝑃</m:t>
+                        </m:r>
+                        <m:d>
+                          <m:dPr>
+                            <m:ctrlPr>
+                              <a:rPr lang="en-US" sz="1400" i="1">
+                                <a:solidFill>
+                                  <a:schemeClr val="tx1"/>
+                                </a:solidFill>
+                                <a:latin typeface="Cambria Math" panose="02040503050406030204" pitchFamily="18" charset="0"/>
+                              </a:rPr>
+                            </m:ctrlPr>
+                          </m:dPr>
+                          <m:e>
+                            <m:r>
+                              <a:rPr lang="en-US" sz="1400" i="1">
+                                <a:solidFill>
+                                  <a:schemeClr val="tx1"/>
+                                </a:solidFill>
+                                <a:latin typeface="Cambria Math" panose="02040503050406030204" pitchFamily="18" charset="0"/>
+                              </a:rPr>
+                              <m:t>𝑐ℎ𝑜𝑜𝑠𝑒</m:t>
+                            </m:r>
+                            <m:r>
+                              <a:rPr lang="en-US" sz="1400" i="1">
+                                <a:solidFill>
+                                  <a:schemeClr val="tx1"/>
+                                </a:solidFill>
+                                <a:latin typeface="Cambria Math" panose="02040503050406030204" pitchFamily="18" charset="0"/>
+                              </a:rPr>
+                              <m:t> </m:t>
+                            </m:r>
+                            <m:sSub>
+                              <m:sSubPr>
+                                <m:ctrlPr>
+                                  <a:rPr lang="en-US" sz="1400" i="1">
+                                    <a:solidFill>
+                                      <a:schemeClr val="tx1"/>
+                                    </a:solidFill>
+                                    <a:latin typeface="Cambria Math" panose="02040503050406030204" pitchFamily="18" charset="0"/>
+                                  </a:rPr>
+                                </m:ctrlPr>
+                              </m:sSubPr>
+                              <m:e>
+                                <m:r>
+                                  <a:rPr lang="en-US" sz="1400" i="1">
+                                    <a:solidFill>
+                                      <a:schemeClr val="tx1"/>
+                                    </a:solidFill>
+                                    <a:latin typeface="Cambria Math" panose="02040503050406030204" pitchFamily="18" charset="0"/>
+                                  </a:rPr>
+                                  <m:t>𝐻</m:t>
+                                </m:r>
+                              </m:e>
+                              <m:sub>
+                                <m:r>
+                                  <a:rPr lang="en-US" sz="1400" b="0" i="1" smtClean="0">
+                                    <a:solidFill>
+                                      <a:schemeClr val="tx1"/>
+                                    </a:solidFill>
+                                    <a:latin typeface="Cambria Math" panose="02040503050406030204" pitchFamily="18" charset="0"/>
+                                  </a:rPr>
+                                  <m:t>0</m:t>
+                                </m:r>
+                              </m:sub>
+                            </m:sSub>
+                          </m:e>
+                        </m:d>
+                      </m:oMath>
+                    </m:oMathPara>
+                  </a14:m>
+                  <a:endParaRPr lang="en-US" sz="1400" dirty="0">
+                    <a:solidFill>
+                      <a:schemeClr val="tx1"/>
+                    </a:solidFill>
+                  </a:endParaRPr>
+                </a:p>
+              </p:txBody>
+            </p:sp>
+          </mc:Choice>
+          <mc:Fallback>
+            <p:sp>
+              <p:nvSpPr>
+                <p:cNvPr id="10" name="Rounded Rectangle 9">
+                  <a:extLst>
+                    <a:ext uri="{FF2B5EF4-FFF2-40B4-BE49-F238E27FC236}">
+                      <a16:creationId xmlns:a16="http://schemas.microsoft.com/office/drawing/2014/main" id="{6404AE7E-EDBA-2D87-56A7-EB7B9118A568}"/>
+                    </a:ext>
+                  </a:extLst>
+                </p:cNvPr>
+                <p:cNvSpPr>
+                  <a:spLocks noRot="1" noChangeAspect="1" noMove="1" noResize="1" noEditPoints="1" noAdjustHandles="1" noChangeArrowheads="1" noChangeShapeType="1" noTextEdit="1"/>
+                </p:cNvSpPr>
+                <p:nvPr/>
+              </p:nvSpPr>
+              <p:spPr>
+                <a:xfrm>
+                  <a:off x="4414869" y="4447266"/>
+                  <a:ext cx="1060798" cy="453239"/>
+                </a:xfrm>
+                <a:prstGeom prst="roundRect">
+                  <a:avLst/>
+                </a:prstGeom>
+                <a:blipFill>
+                  <a:blip r:embed="rId5"/>
+                  <a:stretch>
+                    <a:fillRect l="-6977"/>
+                  </a:stretch>
+                </a:blipFill>
+                <a:ln>
+                  <a:solidFill>
+                    <a:srgbClr val="B3B3FF"/>
+                  </a:solidFill>
+                </a:ln>
+              </p:spPr>
+              <p:txBody>
+                <a:bodyPr/>
+                <a:lstStyle/>
+                <a:p>
+                  <a:r>
+                    <a:rPr lang="en-US">
+                      <a:noFill/>
+                    </a:rPr>
+                    <a:t> </a:t>
+                  </a:r>
+                </a:p>
+              </p:txBody>
+            </p:sp>
+          </mc:Fallback>
+        </mc:AlternateContent>
+        <mc:AlternateContent xmlns:mc="http://schemas.openxmlformats.org/markup-compatibility/2006">
+          <mc:Choice xmlns:a14="http://schemas.microsoft.com/office/drawing/2010/main" Requires="a14">
+            <p:sp>
+              <p:nvSpPr>
+                <p:cNvPr id="11" name="Rounded Rectangle 10">
+                  <a:extLst>
+                    <a:ext uri="{FF2B5EF4-FFF2-40B4-BE49-F238E27FC236}">
+                      <a16:creationId xmlns:a16="http://schemas.microsoft.com/office/drawing/2014/main" id="{FB2BE54A-EC8A-F02B-28D4-9552E37C1976}"/>
+                    </a:ext>
+                  </a:extLst>
+                </p:cNvPr>
+                <p:cNvSpPr/>
+                <p:nvPr/>
+              </p:nvSpPr>
+              <p:spPr>
+                <a:xfrm>
+                  <a:off x="5601036" y="4447266"/>
+                  <a:ext cx="1060798" cy="453239"/>
+                </a:xfrm>
+                <a:prstGeom prst="roundRect">
+                  <a:avLst/>
+                </a:prstGeom>
                 <a:solidFill>
                   <a:srgbClr val="FFB3B3"/>
                 </a:solidFill>
-              </a:ln>
-            </p:spPr>
-            <p:style>
-              <a:lnRef idx="2">
-                <a:schemeClr val="accent1">
-                  <a:shade val="15000"/>
-                </a:schemeClr>
-              </a:lnRef>
-              <a:fillRef idx="1">
-                <a:schemeClr val="accent1"/>
-              </a:fillRef>
-              <a:effectRef idx="0">
-                <a:schemeClr val="accent1"/>
-              </a:effectRef>
-              <a:fontRef idx="minor">
-                <a:schemeClr val="lt1"/>
-              </a:fontRef>
-            </p:style>
-            <p:txBody>
-              <a:bodyPr rtlCol="0" anchor="ctr"/>
-              <a:lstStyle/>
-              <a:p>
-                <a:pPr algn="ctr"/>
-                <a14:m>
-                  <m:oMathPara xmlns:m="http://schemas.openxmlformats.org/officeDocument/2006/math">
-                    <m:oMath>
-                      <m:r>
-                        <a:rPr lang="en-US" sz="1400" i="1" smtClean="0">
-                          <a:solidFill>
-                            <a:schemeClr val="tx1"/>
-                          </a:solidFill>
-                          <a:latin typeface="Cambria Math" panose="02040503050406030204" pitchFamily="18" charset="0"/>
-                        </a:rPr>
-                        <m:t>𝑃</m:t>
-                      </m:r>
-                      <m:d>
-                        <m:dPr>
-                          <m:ctrlPr>
-                            <a:rPr lang="en-US" sz="1400" i="1">
-                              <a:solidFill>
-                                <a:schemeClr val="tx1"/>
-                              </a:solidFill>
-                              <a:latin typeface="Cambria Math" panose="02040503050406030204" pitchFamily="18" charset="0"/>
-                            </a:rPr>
-                          </m:ctrlPr>
-                        </m:dPr>
-                        <m:e>
-                          <m:r>
-                            <a:rPr lang="en-US" sz="1400" i="1">
-                              <a:solidFill>
-                                <a:schemeClr val="tx1"/>
-                              </a:solidFill>
-                              <a:latin typeface="Cambria Math" panose="02040503050406030204" pitchFamily="18" charset="0"/>
-                            </a:rPr>
-                            <m:t>𝑐ℎ𝑜𝑜𝑠𝑒</m:t>
-                          </m:r>
-                          <m:r>
-                            <a:rPr lang="en-US" sz="1400" i="1">
-                              <a:solidFill>
-                                <a:schemeClr val="tx1"/>
-                              </a:solidFill>
-                              <a:latin typeface="Cambria Math" panose="02040503050406030204" pitchFamily="18" charset="0"/>
-                            </a:rPr>
-                            <m:t> </m:t>
-                          </m:r>
-                          <m:r>
-                            <a:rPr lang="en-US" sz="1400" b="0" i="1" smtClean="0">
-                              <a:solidFill>
-                                <a:schemeClr val="tx1"/>
-                              </a:solidFill>
-                              <a:latin typeface="Cambria Math" panose="02040503050406030204" pitchFamily="18" charset="0"/>
-                            </a:rPr>
-                            <m:t>𝐵</m:t>
-                          </m:r>
-                        </m:e>
-                      </m:d>
-                    </m:oMath>
-                  </m:oMathPara>
-                </a14:m>
-                <a:endParaRPr lang="en-US" sz="1400" dirty="0">
+                <a:ln>
                   <a:solidFill>
-                    <a:schemeClr val="tx1"/>
+                    <a:srgbClr val="FFB3B3"/>
                   </a:solidFill>
-                </a:endParaRPr>
-              </a:p>
-            </p:txBody>
-          </p:sp>
-        </mc:Choice>
-        <mc:Fallback xmlns="">
-          <p:sp>
-            <p:nvSpPr>
-              <p:cNvPr id="11" name="Rounded Rectangle 10">
-                <a:extLst>
-                  <a:ext uri="{FF2B5EF4-FFF2-40B4-BE49-F238E27FC236}">
-                    <a16:creationId xmlns:a16="http://schemas.microsoft.com/office/drawing/2014/main" id="{FB2BE54A-EC8A-F02B-28D4-9552E37C1976}"/>
-                  </a:ext>
-                </a:extLst>
-              </p:cNvPr>
-              <p:cNvSpPr>
-                <a:spLocks noRot="1" noChangeAspect="1" noMove="1" noResize="1" noEditPoints="1" noAdjustHandles="1" noChangeArrowheads="1" noChangeShapeType="1" noTextEdit="1"/>
-              </p:cNvSpPr>
-              <p:nvPr/>
-            </p:nvSpPr>
-            <p:spPr>
-              <a:xfrm>
-                <a:off x="5601036" y="4447266"/>
-                <a:ext cx="1060798" cy="453239"/>
-              </a:xfrm>
-              <a:prstGeom prst="roundRect">
-                <a:avLst/>
-              </a:prstGeom>
-              <a:blipFill>
-                <a:blip r:embed="rId6"/>
-                <a:stretch>
-                  <a:fillRect l="-2326"/>
-                </a:stretch>
-              </a:blipFill>
-              <a:ln>
-                <a:solidFill>
-                  <a:srgbClr val="FFB3B3"/>
-                </a:solidFill>
-              </a:ln>
-            </p:spPr>
-            <p:txBody>
-              <a:bodyPr/>
-              <a:lstStyle/>
-              <a:p>
-                <a:r>
-                  <a:rPr lang="en-US">
-                    <a:noFill/>
-                  </a:rPr>
-                  <a:t> </a:t>
-                </a:r>
-              </a:p>
-            </p:txBody>
-          </p:sp>
-        </mc:Fallback>
-      </mc:AlternateContent>
-      <mc:AlternateContent xmlns:mc="http://schemas.openxmlformats.org/markup-compatibility/2006" xmlns:a14="http://schemas.microsoft.com/office/drawing/2010/main">
-        <mc:Choice Requires="a14">
-          <p:sp>
-            <p:nvSpPr>
-              <p:cNvPr id="12" name="Rounded Rectangle 11">
-                <a:extLst>
-                  <a:ext uri="{FF2B5EF4-FFF2-40B4-BE49-F238E27FC236}">
-                    <a16:creationId xmlns:a16="http://schemas.microsoft.com/office/drawing/2014/main" id="{1A981A21-28B1-79A1-2FA3-0E3652847271}"/>
-                  </a:ext>
-                </a:extLst>
-              </p:cNvPr>
-              <p:cNvSpPr/>
-              <p:nvPr/>
-            </p:nvSpPr>
-            <p:spPr>
-              <a:xfrm>
-                <a:off x="6751766" y="4447266"/>
-                <a:ext cx="1060798" cy="453239"/>
-              </a:xfrm>
-              <a:prstGeom prst="roundRect">
-                <a:avLst/>
-              </a:prstGeom>
-              <a:solidFill>
-                <a:srgbClr val="AFD4AF"/>
-              </a:solidFill>
-              <a:ln>
+                </a:ln>
+              </p:spPr>
+              <p:style>
+                <a:lnRef idx="2">
+                  <a:schemeClr val="accent1">
+                    <a:shade val="15000"/>
+                  </a:schemeClr>
+                </a:lnRef>
+                <a:fillRef idx="1">
+                  <a:schemeClr val="accent1"/>
+                </a:fillRef>
+                <a:effectRef idx="0">
+                  <a:schemeClr val="accent1"/>
+                </a:effectRef>
+                <a:fontRef idx="minor">
+                  <a:schemeClr val="lt1"/>
+                </a:fontRef>
+              </p:style>
+              <p:txBody>
+                <a:bodyPr rtlCol="0" anchor="ctr"/>
+                <a:lstStyle/>
+                <a:p>
+                  <a:pPr algn="ctr"/>
+                  <a14:m>
+                    <m:oMathPara xmlns:m="http://schemas.openxmlformats.org/officeDocument/2006/math">
+                      <m:oMath>
+                        <m:r>
+                          <a:rPr lang="en-US" sz="1400" i="1" smtClean="0">
+                            <a:solidFill>
+                              <a:schemeClr val="tx1"/>
+                            </a:solidFill>
+                            <a:latin typeface="Cambria Math" panose="02040503050406030204" pitchFamily="18" charset="0"/>
+                          </a:rPr>
+                          <m:t>𝑃</m:t>
+                        </m:r>
+                        <m:d>
+                          <m:dPr>
+                            <m:ctrlPr>
+                              <a:rPr lang="en-US" sz="1400" i="1">
+                                <a:solidFill>
+                                  <a:schemeClr val="tx1"/>
+                                </a:solidFill>
+                                <a:latin typeface="Cambria Math" panose="02040503050406030204" pitchFamily="18" charset="0"/>
+                              </a:rPr>
+                            </m:ctrlPr>
+                          </m:dPr>
+                          <m:e>
+                            <m:r>
+                              <a:rPr lang="en-US" sz="1400" i="1">
+                                <a:solidFill>
+                                  <a:schemeClr val="tx1"/>
+                                </a:solidFill>
+                                <a:latin typeface="Cambria Math" panose="02040503050406030204" pitchFamily="18" charset="0"/>
+                              </a:rPr>
+                              <m:t>𝑐ℎ𝑜𝑜𝑠𝑒</m:t>
+                            </m:r>
+                            <m:r>
+                              <a:rPr lang="en-US" sz="1400" i="1">
+                                <a:solidFill>
+                                  <a:schemeClr val="tx1"/>
+                                </a:solidFill>
+                                <a:latin typeface="Cambria Math" panose="02040503050406030204" pitchFamily="18" charset="0"/>
+                              </a:rPr>
+                              <m:t> </m:t>
+                            </m:r>
+                            <m:sSub>
+                              <m:sSubPr>
+                                <m:ctrlPr>
+                                  <a:rPr lang="en-US" sz="1400" b="0" i="1" smtClean="0">
+                                    <a:solidFill>
+                                      <a:schemeClr val="tx1"/>
+                                    </a:solidFill>
+                                    <a:latin typeface="Cambria Math" panose="02040503050406030204" pitchFamily="18" charset="0"/>
+                                  </a:rPr>
+                                </m:ctrlPr>
+                              </m:sSubPr>
+                              <m:e>
+                                <m:r>
+                                  <a:rPr lang="en-US" sz="1400" b="0" i="1" smtClean="0">
+                                    <a:solidFill>
+                                      <a:schemeClr val="tx1"/>
+                                    </a:solidFill>
+                                    <a:latin typeface="Cambria Math" panose="02040503050406030204" pitchFamily="18" charset="0"/>
+                                  </a:rPr>
+                                  <m:t>𝐻</m:t>
+                                </m:r>
+                              </m:e>
+                              <m:sub>
+                                <m:r>
+                                  <a:rPr lang="en-US" sz="1400" b="0" i="1" smtClean="0">
+                                    <a:solidFill>
+                                      <a:schemeClr val="tx1"/>
+                                    </a:solidFill>
+                                    <a:latin typeface="Cambria Math" panose="02040503050406030204" pitchFamily="18" charset="0"/>
+                                  </a:rPr>
+                                  <m:t>1</m:t>
+                                </m:r>
+                              </m:sub>
+                            </m:sSub>
+                          </m:e>
+                        </m:d>
+                      </m:oMath>
+                    </m:oMathPara>
+                  </a14:m>
+                  <a:endParaRPr lang="en-US" sz="1400" dirty="0">
+                    <a:solidFill>
+                      <a:schemeClr val="tx1"/>
+                    </a:solidFill>
+                  </a:endParaRPr>
+                </a:p>
+              </p:txBody>
+            </p:sp>
+          </mc:Choice>
+          <mc:Fallback>
+            <p:sp>
+              <p:nvSpPr>
+                <p:cNvPr id="11" name="Rounded Rectangle 10">
+                  <a:extLst>
+                    <a:ext uri="{FF2B5EF4-FFF2-40B4-BE49-F238E27FC236}">
+                      <a16:creationId xmlns:a16="http://schemas.microsoft.com/office/drawing/2014/main" id="{FB2BE54A-EC8A-F02B-28D4-9552E37C1976}"/>
+                    </a:ext>
+                  </a:extLst>
+                </p:cNvPr>
+                <p:cNvSpPr>
+                  <a:spLocks noRot="1" noChangeAspect="1" noMove="1" noResize="1" noEditPoints="1" noAdjustHandles="1" noChangeArrowheads="1" noChangeShapeType="1" noTextEdit="1"/>
+                </p:cNvSpPr>
+                <p:nvPr/>
+              </p:nvSpPr>
+              <p:spPr>
+                <a:xfrm>
+                  <a:off x="5601036" y="4447266"/>
+                  <a:ext cx="1060798" cy="453239"/>
+                </a:xfrm>
+                <a:prstGeom prst="roundRect">
+                  <a:avLst/>
+                </a:prstGeom>
+                <a:blipFill>
+                  <a:blip r:embed="rId6"/>
+                  <a:stretch>
+                    <a:fillRect l="-5814"/>
+                  </a:stretch>
+                </a:blipFill>
+                <a:ln>
+                  <a:solidFill>
+                    <a:srgbClr val="FFB3B3"/>
+                  </a:solidFill>
+                </a:ln>
+              </p:spPr>
+              <p:txBody>
+                <a:bodyPr/>
+                <a:lstStyle/>
+                <a:p>
+                  <a:r>
+                    <a:rPr lang="en-US">
+                      <a:noFill/>
+                    </a:rPr>
+                    <a:t> </a:t>
+                  </a:r>
+                </a:p>
+              </p:txBody>
+            </p:sp>
+          </mc:Fallback>
+        </mc:AlternateContent>
+        <mc:AlternateContent xmlns:mc="http://schemas.openxmlformats.org/markup-compatibility/2006">
+          <mc:Choice xmlns:a14="http://schemas.microsoft.com/office/drawing/2010/main" Requires="a14">
+            <p:sp>
+              <p:nvSpPr>
+                <p:cNvPr id="12" name="Rounded Rectangle 11">
+                  <a:extLst>
+                    <a:ext uri="{FF2B5EF4-FFF2-40B4-BE49-F238E27FC236}">
+                      <a16:creationId xmlns:a16="http://schemas.microsoft.com/office/drawing/2014/main" id="{1A981A21-28B1-79A1-2FA3-0E3652847271}"/>
+                    </a:ext>
+                  </a:extLst>
+                </p:cNvPr>
+                <p:cNvSpPr/>
+                <p:nvPr/>
+              </p:nvSpPr>
+              <p:spPr>
+                <a:xfrm>
+                  <a:off x="6751766" y="4447266"/>
+                  <a:ext cx="1060798" cy="453239"/>
+                </a:xfrm>
+                <a:prstGeom prst="roundRect">
+                  <a:avLst/>
+                </a:prstGeom>
                 <a:solidFill>
                   <a:srgbClr val="AFD4AF"/>
                 </a:solidFill>
-              </a:ln>
-            </p:spPr>
-            <p:style>
-              <a:lnRef idx="2">
-                <a:schemeClr val="accent1">
-                  <a:shade val="15000"/>
+                <a:ln>
+                  <a:solidFill>
+                    <a:srgbClr val="AFD4AF"/>
+                  </a:solidFill>
+                </a:ln>
+              </p:spPr>
+              <p:style>
+                <a:lnRef idx="2">
+                  <a:schemeClr val="accent1">
+                    <a:shade val="15000"/>
+                  </a:schemeClr>
+                </a:lnRef>
+                <a:fillRef idx="1">
+                  <a:schemeClr val="accent1"/>
+                </a:fillRef>
+                <a:effectRef idx="0">
+                  <a:schemeClr val="accent1"/>
+                </a:effectRef>
+                <a:fontRef idx="minor">
+                  <a:schemeClr val="lt1"/>
+                </a:fontRef>
+              </p:style>
+              <p:txBody>
+                <a:bodyPr rtlCol="0" anchor="ctr"/>
+                <a:lstStyle/>
+                <a:p>
+                  <a:pPr algn="ctr"/>
+                  <a14:m>
+                    <m:oMathPara xmlns:m="http://schemas.openxmlformats.org/officeDocument/2006/math">
+                      <m:oMath>
+                        <m:r>
+                          <a:rPr lang="en-US" sz="1400" b="0" i="1" smtClean="0">
+                            <a:solidFill>
+                              <a:schemeClr val="tx1"/>
+                            </a:solidFill>
+                            <a:latin typeface="Cambria Math" panose="02040503050406030204" pitchFamily="18" charset="0"/>
+                          </a:rPr>
+                          <m:t>𝑃</m:t>
+                        </m:r>
+                        <m:r>
+                          <a:rPr lang="en-US" sz="1400" b="0" i="1" smtClean="0">
+                            <a:solidFill>
+                              <a:schemeClr val="tx1"/>
+                            </a:solidFill>
+                            <a:latin typeface="Cambria Math" panose="02040503050406030204" pitchFamily="18" charset="0"/>
+                          </a:rPr>
+                          <m:t>(</m:t>
+                        </m:r>
+                        <m:r>
+                          <a:rPr lang="en-US" sz="1400" b="0" i="1" smtClean="0">
+                            <a:solidFill>
+                              <a:schemeClr val="tx1"/>
+                            </a:solidFill>
+                            <a:latin typeface="Cambria Math" panose="02040503050406030204" pitchFamily="18" charset="0"/>
+                          </a:rPr>
+                          <m:t>𝑠𝑎𝑚𝑝𝑙𝑒</m:t>
+                        </m:r>
+                        <m:r>
+                          <a:rPr lang="en-US" sz="1400" b="0" i="1" smtClean="0">
+                            <a:solidFill>
+                              <a:schemeClr val="tx1"/>
+                            </a:solidFill>
+                            <a:latin typeface="Cambria Math" panose="02040503050406030204" pitchFamily="18" charset="0"/>
+                          </a:rPr>
+                          <m:t>)</m:t>
+                        </m:r>
+                      </m:oMath>
+                    </m:oMathPara>
+                  </a14:m>
+                  <a:endParaRPr lang="en-US" sz="1400" dirty="0">
+                    <a:solidFill>
+                      <a:schemeClr val="tx1"/>
+                    </a:solidFill>
+                  </a:endParaRPr>
+                </a:p>
+              </p:txBody>
+            </p:sp>
+          </mc:Choice>
+          <mc:Fallback>
+            <p:sp>
+              <p:nvSpPr>
+                <p:cNvPr id="12" name="Rounded Rectangle 11">
+                  <a:extLst>
+                    <a:ext uri="{FF2B5EF4-FFF2-40B4-BE49-F238E27FC236}">
+                      <a16:creationId xmlns:a16="http://schemas.microsoft.com/office/drawing/2014/main" id="{1A981A21-28B1-79A1-2FA3-0E3652847271}"/>
+                    </a:ext>
+                  </a:extLst>
+                </p:cNvPr>
+                <p:cNvSpPr>
+                  <a:spLocks noRot="1" noChangeAspect="1" noMove="1" noResize="1" noEditPoints="1" noAdjustHandles="1" noChangeArrowheads="1" noChangeShapeType="1" noTextEdit="1"/>
+                </p:cNvSpPr>
+                <p:nvPr/>
+              </p:nvSpPr>
+              <p:spPr>
+                <a:xfrm>
+                  <a:off x="6751766" y="4447266"/>
+                  <a:ext cx="1060798" cy="453239"/>
+                </a:xfrm>
+                <a:prstGeom prst="roundRect">
+                  <a:avLst/>
+                </a:prstGeom>
+                <a:blipFill>
+                  <a:blip r:embed="rId7"/>
+                  <a:stretch>
+                    <a:fillRect/>
+                  </a:stretch>
+                </a:blipFill>
+                <a:ln>
+                  <a:solidFill>
+                    <a:srgbClr val="AFD4AF"/>
+                  </a:solidFill>
+                </a:ln>
+              </p:spPr>
+              <p:txBody>
+                <a:bodyPr/>
+                <a:lstStyle/>
+                <a:p>
+                  <a:r>
+                    <a:rPr lang="en-US">
+                      <a:noFill/>
+                    </a:rPr>
+                    <a:t> </a:t>
+                  </a:r>
+                </a:p>
+              </p:txBody>
+            </p:sp>
+          </mc:Fallback>
+        </mc:AlternateContent>
+        <p:cxnSp>
+          <p:nvCxnSpPr>
+            <p:cNvPr id="13" name="Elbow Connector 12">
+              <a:extLst>
+                <a:ext uri="{FF2B5EF4-FFF2-40B4-BE49-F238E27FC236}">
+                  <a16:creationId xmlns:a16="http://schemas.microsoft.com/office/drawing/2014/main" id="{1FA2DC89-52EC-5E68-CE68-0742126D5E3A}"/>
+                </a:ext>
+              </a:extLst>
+            </p:cNvPr>
+            <p:cNvCxnSpPr>
+              <a:cxnSpLocks/>
+              <a:endCxn id="5" idx="3"/>
+            </p:cNvCxnSpPr>
+            <p:nvPr/>
+          </p:nvCxnSpPr>
+          <p:spPr>
+            <a:xfrm flipV="1">
+              <a:off x="6095997" y="3403078"/>
+              <a:ext cx="1806501" cy="638545"/>
+            </a:xfrm>
+            <a:prstGeom prst="bentConnector3">
+              <a:avLst>
+                <a:gd name="adj1" fmla="val 112654"/>
+              </a:avLst>
+            </a:prstGeom>
+            <a:ln>
+              <a:tailEnd type="triangle"/>
+            </a:ln>
+          </p:spPr>
+          <p:style>
+            <a:lnRef idx="2">
+              <a:schemeClr val="dk1"/>
+            </a:lnRef>
+            <a:fillRef idx="0">
+              <a:schemeClr val="dk1"/>
+            </a:fillRef>
+            <a:effectRef idx="1">
+              <a:schemeClr val="dk1"/>
+            </a:effectRef>
+            <a:fontRef idx="minor">
+              <a:schemeClr val="tx1"/>
+            </a:fontRef>
+          </p:style>
+        </p:cxnSp>
+        <p:sp>
+          <p:nvSpPr>
+            <p:cNvPr id="14" name="TextBox 13">
+              <a:extLst>
+                <a:ext uri="{FF2B5EF4-FFF2-40B4-BE49-F238E27FC236}">
+                  <a16:creationId xmlns:a16="http://schemas.microsoft.com/office/drawing/2014/main" id="{56118D8F-FA52-344C-2C0B-A7D15B2E5499}"/>
+                </a:ext>
+              </a:extLst>
+            </p:cNvPr>
+            <p:cNvSpPr txBox="1"/>
+            <p:nvPr/>
+          </p:nvSpPr>
+          <p:spPr>
+            <a:xfrm>
+              <a:off x="3436801" y="1915797"/>
+              <a:ext cx="647934" cy="338554"/>
+            </a:xfrm>
+            <a:prstGeom prst="rect">
+              <a:avLst/>
+            </a:prstGeom>
+            <a:noFill/>
+          </p:spPr>
+          <p:txBody>
+            <a:bodyPr wrap="none" rtlCol="0">
+              <a:spAutoFit/>
+            </a:bodyPr>
+            <a:lstStyle/>
+            <a:p>
+              <a:r>
+                <a:rPr lang="en-US" sz="1600" dirty="0">
+                  <a:latin typeface="Arial" panose="020B0604020202020204" pitchFamily="34" charset="0"/>
+                  <a:cs typeface="Arial" panose="020B0604020202020204" pitchFamily="34" charset="0"/>
+                </a:rPr>
+                <a:t>Input</a:t>
+              </a:r>
+            </a:p>
+          </p:txBody>
+        </p:sp>
+        <p:sp>
+          <p:nvSpPr>
+            <p:cNvPr id="15" name="TextBox 14">
+              <a:extLst>
+                <a:ext uri="{FF2B5EF4-FFF2-40B4-BE49-F238E27FC236}">
+                  <a16:creationId xmlns:a16="http://schemas.microsoft.com/office/drawing/2014/main" id="{76CB0AEA-2AD3-6D73-4737-2717BCE2C7E4}"/>
+                </a:ext>
+              </a:extLst>
+            </p:cNvPr>
+            <p:cNvSpPr txBox="1"/>
+            <p:nvPr/>
+          </p:nvSpPr>
+          <p:spPr>
+            <a:xfrm>
+              <a:off x="3275930" y="3191643"/>
+              <a:ext cx="832279" cy="338554"/>
+            </a:xfrm>
+            <a:prstGeom prst="rect">
+              <a:avLst/>
+            </a:prstGeom>
+            <a:noFill/>
+          </p:spPr>
+          <p:txBody>
+            <a:bodyPr wrap="none" rtlCol="0">
+              <a:spAutoFit/>
+            </a:bodyPr>
+            <a:lstStyle/>
+            <a:p>
+              <a:r>
+                <a:rPr lang="en-US" sz="1600" dirty="0">
+                  <a:latin typeface="Arial" panose="020B0604020202020204" pitchFamily="34" charset="0"/>
+                  <a:cs typeface="Arial" panose="020B0604020202020204" pitchFamily="34" charset="0"/>
+                </a:rPr>
+                <a:t>Hidden</a:t>
+              </a:r>
+            </a:p>
+          </p:txBody>
+        </p:sp>
+        <p:sp>
+          <p:nvSpPr>
+            <p:cNvPr id="16" name="TextBox 15">
+              <a:extLst>
+                <a:ext uri="{FF2B5EF4-FFF2-40B4-BE49-F238E27FC236}">
+                  <a16:creationId xmlns:a16="http://schemas.microsoft.com/office/drawing/2014/main" id="{9F0FC5BD-72CC-B31D-E5D0-23904A255CBA}"/>
+                </a:ext>
+              </a:extLst>
+            </p:cNvPr>
+            <p:cNvSpPr txBox="1"/>
+            <p:nvPr/>
+          </p:nvSpPr>
+          <p:spPr>
+            <a:xfrm>
+              <a:off x="3289297" y="4472643"/>
+              <a:ext cx="801823" cy="338554"/>
+            </a:xfrm>
+            <a:prstGeom prst="rect">
+              <a:avLst/>
+            </a:prstGeom>
+            <a:noFill/>
+          </p:spPr>
+          <p:txBody>
+            <a:bodyPr wrap="none" rtlCol="0">
+              <a:spAutoFit/>
+            </a:bodyPr>
+            <a:lstStyle/>
+            <a:p>
+              <a:r>
+                <a:rPr lang="en-US" sz="1600" dirty="0">
+                  <a:latin typeface="Arial" panose="020B0604020202020204" pitchFamily="34" charset="0"/>
+                  <a:cs typeface="Arial" panose="020B0604020202020204" pitchFamily="34" charset="0"/>
+                </a:rPr>
+                <a:t>Output</a:t>
+              </a:r>
+            </a:p>
+          </p:txBody>
+        </p:sp>
+        <p:sp>
+          <p:nvSpPr>
+            <p:cNvPr id="17" name="Arc 16">
+              <a:extLst>
+                <a:ext uri="{FF2B5EF4-FFF2-40B4-BE49-F238E27FC236}">
+                  <a16:creationId xmlns:a16="http://schemas.microsoft.com/office/drawing/2014/main" id="{0EB1F359-0CB3-2279-BE82-4986FE50CF9D}"/>
+                </a:ext>
+              </a:extLst>
+            </p:cNvPr>
+            <p:cNvSpPr/>
+            <p:nvPr/>
+          </p:nvSpPr>
+          <p:spPr>
+            <a:xfrm rot="18858578">
+              <a:off x="5294259" y="3098638"/>
+              <a:ext cx="1535096" cy="1572542"/>
+            </a:xfrm>
+            <a:prstGeom prst="arc">
+              <a:avLst>
+                <a:gd name="adj1" fmla="val 16157885"/>
+                <a:gd name="adj2" fmla="val 0"/>
+              </a:avLst>
+            </a:prstGeom>
+          </p:spPr>
+          <p:style>
+            <a:lnRef idx="2">
+              <a:schemeClr val="accent1"/>
+            </a:lnRef>
+            <a:fillRef idx="0">
+              <a:schemeClr val="accent1"/>
+            </a:fillRef>
+            <a:effectRef idx="1">
+              <a:schemeClr val="accent1"/>
+            </a:effectRef>
+            <a:fontRef idx="minor">
+              <a:schemeClr val="tx1"/>
+            </a:fontRef>
+          </p:style>
+          <p:txBody>
+            <a:bodyPr rtlCol="0" anchor="ctr"/>
+            <a:lstStyle/>
+            <a:p>
+              <a:pPr algn="ctr"/>
+              <a:endParaRPr lang="en-US" dirty="0"/>
+            </a:p>
+          </p:txBody>
+        </p:sp>
+        <p:sp>
+          <p:nvSpPr>
+            <p:cNvPr id="18" name="Arc 17">
+              <a:extLst>
+                <a:ext uri="{FF2B5EF4-FFF2-40B4-BE49-F238E27FC236}">
+                  <a16:creationId xmlns:a16="http://schemas.microsoft.com/office/drawing/2014/main" id="{F44CF179-E0CE-5B4E-20BF-850E5FB85ADB}"/>
+                </a:ext>
+              </a:extLst>
+            </p:cNvPr>
+            <p:cNvSpPr/>
+            <p:nvPr/>
+          </p:nvSpPr>
+          <p:spPr>
+            <a:xfrm rot="8017476">
+              <a:off x="5251506" y="2148293"/>
+              <a:ext cx="1535096" cy="1572542"/>
+            </a:xfrm>
+            <a:prstGeom prst="arc">
+              <a:avLst>
+                <a:gd name="adj1" fmla="val 16157885"/>
+                <a:gd name="adj2" fmla="val 0"/>
+              </a:avLst>
+            </a:prstGeom>
+          </p:spPr>
+          <p:style>
+            <a:lnRef idx="2">
+              <a:schemeClr val="accent1"/>
+            </a:lnRef>
+            <a:fillRef idx="0">
+              <a:schemeClr val="accent1"/>
+            </a:fillRef>
+            <a:effectRef idx="1">
+              <a:schemeClr val="accent1"/>
+            </a:effectRef>
+            <a:fontRef idx="minor">
+              <a:schemeClr val="tx1"/>
+            </a:fontRef>
+          </p:style>
+          <p:txBody>
+            <a:bodyPr rtlCol="0" anchor="ctr"/>
+            <a:lstStyle/>
+            <a:p>
+              <a:pPr algn="ctr"/>
+              <a:endParaRPr lang="en-US" dirty="0"/>
+            </a:p>
+          </p:txBody>
+        </p:sp>
+        <p:sp>
+          <p:nvSpPr>
+            <p:cNvPr id="19" name="Oval 18">
+              <a:extLst>
+                <a:ext uri="{FF2B5EF4-FFF2-40B4-BE49-F238E27FC236}">
+                  <a16:creationId xmlns:a16="http://schemas.microsoft.com/office/drawing/2014/main" id="{8D16355A-BA60-071C-E137-B444D5A4B6DC}"/>
+                </a:ext>
+              </a:extLst>
+            </p:cNvPr>
+            <p:cNvSpPr>
+              <a:spLocks noChangeAspect="1"/>
+            </p:cNvSpPr>
+            <p:nvPr/>
+          </p:nvSpPr>
+          <p:spPr>
+            <a:xfrm>
+              <a:off x="6509991" y="3252920"/>
+              <a:ext cx="110355" cy="108000"/>
+            </a:xfrm>
+            <a:prstGeom prst="ellipse">
+              <a:avLst/>
+            </a:prstGeom>
+            <a:ln>
+              <a:solidFill>
+                <a:schemeClr val="tx2">
+                  <a:lumMod val="75000"/>
+                  <a:lumOff val="25000"/>
                 </a:schemeClr>
-              </a:lnRef>
-              <a:fillRef idx="1">
-                <a:schemeClr val="accent1"/>
-              </a:fillRef>
-              <a:effectRef idx="0">
-                <a:schemeClr val="accent1"/>
-              </a:effectRef>
-              <a:fontRef idx="minor">
-                <a:schemeClr val="lt1"/>
-              </a:fontRef>
-            </p:style>
-            <p:txBody>
-              <a:bodyPr rtlCol="0" anchor="ctr"/>
-              <a:lstStyle/>
-              <a:p>
-                <a:pPr algn="ctr"/>
-                <a14:m>
-                  <m:oMathPara xmlns:m="http://schemas.openxmlformats.org/officeDocument/2006/math">
-                    <m:oMath>
-                      <m:r>
-                        <a:rPr lang="en-US" sz="1400" b="0" i="1" smtClean="0">
-                          <a:solidFill>
-                            <a:schemeClr val="tx1"/>
-                          </a:solidFill>
-                          <a:latin typeface="Cambria Math" panose="02040503050406030204" pitchFamily="18" charset="0"/>
-                        </a:rPr>
-                        <m:t>𝑃</m:t>
-                      </m:r>
-                      <m:r>
-                        <a:rPr lang="en-US" sz="1400" b="0" i="1" smtClean="0">
-                          <a:solidFill>
-                            <a:schemeClr val="tx1"/>
-                          </a:solidFill>
-                          <a:latin typeface="Cambria Math" panose="02040503050406030204" pitchFamily="18" charset="0"/>
-                        </a:rPr>
-                        <m:t>(</m:t>
-                      </m:r>
-                      <m:r>
-                        <a:rPr lang="en-US" sz="1400" b="0" i="1" smtClean="0">
-                          <a:solidFill>
-                            <a:schemeClr val="tx1"/>
-                          </a:solidFill>
-                          <a:latin typeface="Cambria Math" panose="02040503050406030204" pitchFamily="18" charset="0"/>
-                        </a:rPr>
-                        <m:t>𝑠𝑎𝑚𝑝𝑙𝑒</m:t>
-                      </m:r>
-                      <m:r>
-                        <a:rPr lang="en-US" sz="1400" b="0" i="1" smtClean="0">
-                          <a:solidFill>
-                            <a:schemeClr val="tx1"/>
-                          </a:solidFill>
-                          <a:latin typeface="Cambria Math" panose="02040503050406030204" pitchFamily="18" charset="0"/>
-                        </a:rPr>
-                        <m:t>)</m:t>
-                      </m:r>
-                    </m:oMath>
-                  </m:oMathPara>
-                </a14:m>
-                <a:endParaRPr lang="en-US" sz="1400" dirty="0">
-                  <a:solidFill>
-                    <a:schemeClr val="tx1"/>
-                  </a:solidFill>
-                </a:endParaRPr>
-              </a:p>
-            </p:txBody>
-          </p:sp>
-        </mc:Choice>
-        <mc:Fallback xmlns="">
-          <p:sp>
-            <p:nvSpPr>
-              <p:cNvPr id="12" name="Rounded Rectangle 11">
-                <a:extLst>
-                  <a:ext uri="{FF2B5EF4-FFF2-40B4-BE49-F238E27FC236}">
-                    <a16:creationId xmlns:a16="http://schemas.microsoft.com/office/drawing/2014/main" id="{1A981A21-28B1-79A1-2FA3-0E3652847271}"/>
-                  </a:ext>
-                </a:extLst>
-              </p:cNvPr>
-              <p:cNvSpPr>
-                <a:spLocks noRot="1" noChangeAspect="1" noMove="1" noResize="1" noEditPoints="1" noAdjustHandles="1" noChangeArrowheads="1" noChangeShapeType="1" noTextEdit="1"/>
-              </p:cNvSpPr>
-              <p:nvPr/>
-            </p:nvSpPr>
-            <p:spPr>
-              <a:xfrm>
-                <a:off x="6751766" y="4447266"/>
-                <a:ext cx="1060798" cy="453239"/>
-              </a:xfrm>
-              <a:prstGeom prst="roundRect">
-                <a:avLst/>
-              </a:prstGeom>
-              <a:blipFill>
-                <a:blip r:embed="rId7"/>
-                <a:stretch>
-                  <a:fillRect/>
-                </a:stretch>
-              </a:blipFill>
-              <a:ln>
+              </a:solidFill>
+            </a:ln>
+          </p:spPr>
+          <p:style>
+            <a:lnRef idx="2">
+              <a:schemeClr val="accent1">
+                <a:shade val="15000"/>
+              </a:schemeClr>
+            </a:lnRef>
+            <a:fillRef idx="1">
+              <a:schemeClr val="accent1"/>
+            </a:fillRef>
+            <a:effectRef idx="0">
+              <a:schemeClr val="accent1"/>
+            </a:effectRef>
+            <a:fontRef idx="minor">
+              <a:schemeClr val="lt1"/>
+            </a:fontRef>
+          </p:style>
+          <p:txBody>
+            <a:bodyPr rtlCol="0" anchor="ctr"/>
+            <a:lstStyle/>
+            <a:p>
+              <a:pPr algn="ctr"/>
+              <a:endParaRPr lang="en-US"/>
+            </a:p>
+          </p:txBody>
+        </p:sp>
+        <p:sp>
+          <p:nvSpPr>
+            <p:cNvPr id="20" name="Oval 19">
+              <a:extLst>
+                <a:ext uri="{FF2B5EF4-FFF2-40B4-BE49-F238E27FC236}">
+                  <a16:creationId xmlns:a16="http://schemas.microsoft.com/office/drawing/2014/main" id="{EEB09F32-8250-59E3-5820-CBA1FB59A66D}"/>
+                </a:ext>
+              </a:extLst>
+            </p:cNvPr>
+            <p:cNvSpPr>
+              <a:spLocks noChangeAspect="1"/>
+            </p:cNvSpPr>
+            <p:nvPr/>
+          </p:nvSpPr>
+          <p:spPr>
+            <a:xfrm>
+              <a:off x="5458258" y="3455365"/>
+              <a:ext cx="110355" cy="108000"/>
+            </a:xfrm>
+            <a:prstGeom prst="ellipse">
+              <a:avLst/>
+            </a:prstGeom>
+            <a:ln>
+              <a:solidFill>
+                <a:schemeClr val="tx2">
+                  <a:lumMod val="75000"/>
+                  <a:lumOff val="25000"/>
+                </a:schemeClr>
+              </a:solidFill>
+            </a:ln>
+          </p:spPr>
+          <p:style>
+            <a:lnRef idx="2">
+              <a:schemeClr val="accent1">
+                <a:shade val="15000"/>
+              </a:schemeClr>
+            </a:lnRef>
+            <a:fillRef idx="1">
+              <a:schemeClr val="accent1"/>
+            </a:fillRef>
+            <a:effectRef idx="0">
+              <a:schemeClr val="accent1"/>
+            </a:effectRef>
+            <a:fontRef idx="minor">
+              <a:schemeClr val="lt1"/>
+            </a:fontRef>
+          </p:style>
+          <p:txBody>
+            <a:bodyPr rtlCol="0" anchor="ctr"/>
+            <a:lstStyle/>
+            <a:p>
+              <a:pPr algn="ctr"/>
+              <a:endParaRPr lang="en-US"/>
+            </a:p>
+          </p:txBody>
+        </p:sp>
+        <p:sp>
+          <p:nvSpPr>
+            <p:cNvPr id="21" name="Circular Arrow 20">
+              <a:extLst>
+                <a:ext uri="{FF2B5EF4-FFF2-40B4-BE49-F238E27FC236}">
+                  <a16:creationId xmlns:a16="http://schemas.microsoft.com/office/drawing/2014/main" id="{3C2A3DED-BF50-B3D2-555F-09C80CB5E44A}"/>
+                </a:ext>
+              </a:extLst>
+            </p:cNvPr>
+            <p:cNvSpPr/>
+            <p:nvPr/>
+          </p:nvSpPr>
+          <p:spPr>
+            <a:xfrm rot="5219297">
+              <a:off x="7018246" y="2984397"/>
+              <a:ext cx="469232" cy="846767"/>
+            </a:xfrm>
+            <a:prstGeom prst="circularArrow">
+              <a:avLst>
+                <a:gd name="adj1" fmla="val 10859"/>
+                <a:gd name="adj2" fmla="val 1142319"/>
+                <a:gd name="adj3" fmla="val 21277177"/>
+                <a:gd name="adj4" fmla="val 10303396"/>
+                <a:gd name="adj5" fmla="val 0"/>
+              </a:avLst>
+            </a:prstGeom>
+            <a:ln>
+              <a:solidFill>
+                <a:schemeClr val="tx2">
+                  <a:lumMod val="75000"/>
+                  <a:lumOff val="25000"/>
+                </a:schemeClr>
+              </a:solidFill>
+            </a:ln>
+          </p:spPr>
+          <p:style>
+            <a:lnRef idx="2">
+              <a:schemeClr val="accent1">
+                <a:shade val="15000"/>
+              </a:schemeClr>
+            </a:lnRef>
+            <a:fillRef idx="1">
+              <a:schemeClr val="accent1"/>
+            </a:fillRef>
+            <a:effectRef idx="0">
+              <a:schemeClr val="accent1"/>
+            </a:effectRef>
+            <a:fontRef idx="minor">
+              <a:schemeClr val="lt1"/>
+            </a:fontRef>
+          </p:style>
+          <p:txBody>
+            <a:bodyPr rtlCol="0" anchor="ctr"/>
+            <a:lstStyle/>
+            <a:p>
+              <a:pPr algn="ctr"/>
+              <a:endParaRPr lang="en-US">
                 <a:solidFill>
-                  <a:srgbClr val="AFD4AF"/>
+                  <a:schemeClr val="tx1"/>
                 </a:solidFill>
-              </a:ln>
-            </p:spPr>
-            <p:txBody>
-              <a:bodyPr/>
-              <a:lstStyle/>
-              <a:p>
-                <a:r>
-                  <a:rPr lang="en-US">
-                    <a:noFill/>
-                  </a:rPr>
-                  <a:t> </a:t>
-                </a:r>
-              </a:p>
-            </p:txBody>
-          </p:sp>
-        </mc:Fallback>
-      </mc:AlternateContent>
-      <p:cxnSp>
-        <p:nvCxnSpPr>
-          <p:cNvPr id="13" name="Elbow Connector 12">
-            <a:extLst>
-              <a:ext uri="{FF2B5EF4-FFF2-40B4-BE49-F238E27FC236}">
-                <a16:creationId xmlns:a16="http://schemas.microsoft.com/office/drawing/2014/main" id="{1FA2DC89-52EC-5E68-CE68-0742126D5E3A}"/>
-              </a:ext>
-            </a:extLst>
-          </p:cNvPr>
-          <p:cNvCxnSpPr>
-            <a:cxnSpLocks/>
-            <a:endCxn id="5" idx="3"/>
-          </p:cNvCxnSpPr>
-          <p:nvPr/>
-        </p:nvCxnSpPr>
-        <p:spPr>
-          <a:xfrm flipV="1">
-            <a:off x="6095997" y="3403078"/>
-            <a:ext cx="1806501" cy="638545"/>
-          </a:xfrm>
-          <a:prstGeom prst="bentConnector3">
-            <a:avLst>
-              <a:gd name="adj1" fmla="val 112654"/>
-            </a:avLst>
-          </a:prstGeom>
-          <a:ln>
-            <a:tailEnd type="triangle"/>
-          </a:ln>
-        </p:spPr>
-        <p:style>
-          <a:lnRef idx="2">
-            <a:schemeClr val="dk1"/>
-          </a:lnRef>
-          <a:fillRef idx="0">
-            <a:schemeClr val="dk1"/>
-          </a:fillRef>
-          <a:effectRef idx="1">
-            <a:schemeClr val="dk1"/>
-          </a:effectRef>
-          <a:fontRef idx="minor">
-            <a:schemeClr val="tx1"/>
-          </a:fontRef>
-        </p:style>
-      </p:cxnSp>
-      <p:sp>
-        <p:nvSpPr>
-          <p:cNvPr id="14" name="TextBox 13">
-            <a:extLst>
-              <a:ext uri="{FF2B5EF4-FFF2-40B4-BE49-F238E27FC236}">
-                <a16:creationId xmlns:a16="http://schemas.microsoft.com/office/drawing/2014/main" id="{56118D8F-FA52-344C-2C0B-A7D15B2E5499}"/>
-              </a:ext>
-            </a:extLst>
-          </p:cNvPr>
-          <p:cNvSpPr txBox="1"/>
-          <p:nvPr/>
-        </p:nvSpPr>
-        <p:spPr>
-          <a:xfrm>
-            <a:off x="3436801" y="1915797"/>
-            <a:ext cx="647934" cy="338554"/>
-          </a:xfrm>
-          <a:prstGeom prst="rect">
-            <a:avLst/>
-          </a:prstGeom>
-          <a:noFill/>
-        </p:spPr>
-        <p:txBody>
-          <a:bodyPr wrap="none" rtlCol="0">
-            <a:spAutoFit/>
-          </a:bodyPr>
-          <a:lstStyle/>
-          <a:p>
-            <a:r>
-              <a:rPr lang="en-US" sz="1600" dirty="0">
-                <a:latin typeface="Arial" panose="020B0604020202020204" pitchFamily="34" charset="0"/>
-                <a:cs typeface="Arial" panose="020B0604020202020204" pitchFamily="34" charset="0"/>
-              </a:rPr>
-              <a:t>Input</a:t>
-            </a:r>
-          </a:p>
-        </p:txBody>
-      </p:sp>
-      <p:sp>
-        <p:nvSpPr>
-          <p:cNvPr id="15" name="TextBox 14">
-            <a:extLst>
-              <a:ext uri="{FF2B5EF4-FFF2-40B4-BE49-F238E27FC236}">
-                <a16:creationId xmlns:a16="http://schemas.microsoft.com/office/drawing/2014/main" id="{76CB0AEA-2AD3-6D73-4737-2717BCE2C7E4}"/>
-              </a:ext>
-            </a:extLst>
-          </p:cNvPr>
-          <p:cNvSpPr txBox="1"/>
-          <p:nvPr/>
-        </p:nvSpPr>
-        <p:spPr>
-          <a:xfrm>
-            <a:off x="3275930" y="3191643"/>
-            <a:ext cx="832279" cy="338554"/>
-          </a:xfrm>
-          <a:prstGeom prst="rect">
-            <a:avLst/>
-          </a:prstGeom>
-          <a:noFill/>
-        </p:spPr>
-        <p:txBody>
-          <a:bodyPr wrap="none" rtlCol="0">
-            <a:spAutoFit/>
-          </a:bodyPr>
-          <a:lstStyle/>
-          <a:p>
-            <a:r>
-              <a:rPr lang="en-US" sz="1600" dirty="0">
-                <a:latin typeface="Arial" panose="020B0604020202020204" pitchFamily="34" charset="0"/>
-                <a:cs typeface="Arial" panose="020B0604020202020204" pitchFamily="34" charset="0"/>
-              </a:rPr>
-              <a:t>Hidden</a:t>
-            </a:r>
-          </a:p>
-        </p:txBody>
-      </p:sp>
-      <p:sp>
-        <p:nvSpPr>
-          <p:cNvPr id="16" name="TextBox 15">
-            <a:extLst>
-              <a:ext uri="{FF2B5EF4-FFF2-40B4-BE49-F238E27FC236}">
-                <a16:creationId xmlns:a16="http://schemas.microsoft.com/office/drawing/2014/main" id="{9F0FC5BD-72CC-B31D-E5D0-23904A255CBA}"/>
-              </a:ext>
-            </a:extLst>
-          </p:cNvPr>
-          <p:cNvSpPr txBox="1"/>
-          <p:nvPr/>
-        </p:nvSpPr>
-        <p:spPr>
-          <a:xfrm>
-            <a:off x="3289297" y="4472643"/>
-            <a:ext cx="801823" cy="338554"/>
-          </a:xfrm>
-          <a:prstGeom prst="rect">
-            <a:avLst/>
-          </a:prstGeom>
-          <a:noFill/>
-        </p:spPr>
-        <p:txBody>
-          <a:bodyPr wrap="none" rtlCol="0">
-            <a:spAutoFit/>
-          </a:bodyPr>
-          <a:lstStyle/>
-          <a:p>
-            <a:r>
-              <a:rPr lang="en-US" sz="1600" dirty="0">
-                <a:latin typeface="Arial" panose="020B0604020202020204" pitchFamily="34" charset="0"/>
-                <a:cs typeface="Arial" panose="020B0604020202020204" pitchFamily="34" charset="0"/>
-              </a:rPr>
-              <a:t>Output</a:t>
-            </a:r>
-          </a:p>
-        </p:txBody>
-      </p:sp>
-      <p:sp>
-        <p:nvSpPr>
-          <p:cNvPr id="17" name="Arc 16">
-            <a:extLst>
-              <a:ext uri="{FF2B5EF4-FFF2-40B4-BE49-F238E27FC236}">
-                <a16:creationId xmlns:a16="http://schemas.microsoft.com/office/drawing/2014/main" id="{0EB1F359-0CB3-2279-BE82-4986FE50CF9D}"/>
-              </a:ext>
-            </a:extLst>
-          </p:cNvPr>
-          <p:cNvSpPr/>
-          <p:nvPr/>
-        </p:nvSpPr>
-        <p:spPr>
-          <a:xfrm rot="18858578">
-            <a:off x="5294259" y="3098638"/>
-            <a:ext cx="1535096" cy="1572542"/>
-          </a:xfrm>
-          <a:prstGeom prst="arc">
-            <a:avLst>
-              <a:gd name="adj1" fmla="val 16157885"/>
-              <a:gd name="adj2" fmla="val 0"/>
-            </a:avLst>
-          </a:prstGeom>
-        </p:spPr>
-        <p:style>
-          <a:lnRef idx="2">
-            <a:schemeClr val="accent1"/>
-          </a:lnRef>
-          <a:fillRef idx="0">
-            <a:schemeClr val="accent1"/>
-          </a:fillRef>
-          <a:effectRef idx="1">
-            <a:schemeClr val="accent1"/>
-          </a:effectRef>
-          <a:fontRef idx="minor">
-            <a:schemeClr val="tx1"/>
-          </a:fontRef>
-        </p:style>
-        <p:txBody>
-          <a:bodyPr rtlCol="0" anchor="ctr"/>
-          <a:lstStyle/>
-          <a:p>
-            <a:pPr algn="ctr"/>
-            <a:endParaRPr lang="en-US" dirty="0"/>
-          </a:p>
-        </p:txBody>
-      </p:sp>
-      <p:sp>
-        <p:nvSpPr>
-          <p:cNvPr id="18" name="Arc 17">
-            <a:extLst>
-              <a:ext uri="{FF2B5EF4-FFF2-40B4-BE49-F238E27FC236}">
-                <a16:creationId xmlns:a16="http://schemas.microsoft.com/office/drawing/2014/main" id="{F44CF179-E0CE-5B4E-20BF-850E5FB85ADB}"/>
-              </a:ext>
-            </a:extLst>
-          </p:cNvPr>
-          <p:cNvSpPr/>
-          <p:nvPr/>
-        </p:nvSpPr>
-        <p:spPr>
-          <a:xfrm rot="8017476">
-            <a:off x="5251506" y="2148293"/>
-            <a:ext cx="1535096" cy="1572542"/>
-          </a:xfrm>
-          <a:prstGeom prst="arc">
-            <a:avLst>
-              <a:gd name="adj1" fmla="val 16157885"/>
-              <a:gd name="adj2" fmla="val 0"/>
-            </a:avLst>
-          </a:prstGeom>
-        </p:spPr>
-        <p:style>
-          <a:lnRef idx="2">
-            <a:schemeClr val="accent1"/>
-          </a:lnRef>
-          <a:fillRef idx="0">
-            <a:schemeClr val="accent1"/>
-          </a:fillRef>
-          <a:effectRef idx="1">
-            <a:schemeClr val="accent1"/>
-          </a:effectRef>
-          <a:fontRef idx="minor">
-            <a:schemeClr val="tx1"/>
-          </a:fontRef>
-        </p:style>
-        <p:txBody>
-          <a:bodyPr rtlCol="0" anchor="ctr"/>
-          <a:lstStyle/>
-          <a:p>
-            <a:pPr algn="ctr"/>
-            <a:endParaRPr lang="en-US" dirty="0"/>
-          </a:p>
-        </p:txBody>
-      </p:sp>
-      <p:sp>
-        <p:nvSpPr>
-          <p:cNvPr id="19" name="Oval 18">
-            <a:extLst>
-              <a:ext uri="{FF2B5EF4-FFF2-40B4-BE49-F238E27FC236}">
-                <a16:creationId xmlns:a16="http://schemas.microsoft.com/office/drawing/2014/main" id="{8D16355A-BA60-071C-E137-B444D5A4B6DC}"/>
-              </a:ext>
-            </a:extLst>
-          </p:cNvPr>
-          <p:cNvSpPr>
-            <a:spLocks noChangeAspect="1"/>
-          </p:cNvSpPr>
-          <p:nvPr/>
-        </p:nvSpPr>
-        <p:spPr>
-          <a:xfrm>
-            <a:off x="6509991" y="3252920"/>
-            <a:ext cx="110355" cy="108000"/>
-          </a:xfrm>
-          <a:prstGeom prst="ellipse">
-            <a:avLst/>
-          </a:prstGeom>
-          <a:ln>
-            <a:solidFill>
-              <a:schemeClr val="tx2">
-                <a:lumMod val="75000"/>
-                <a:lumOff val="25000"/>
+              </a:endParaRPr>
+            </a:p>
+          </p:txBody>
+        </p:sp>
+        <p:sp>
+          <p:nvSpPr>
+            <p:cNvPr id="22" name="Oval 21">
+              <a:extLst>
+                <a:ext uri="{FF2B5EF4-FFF2-40B4-BE49-F238E27FC236}">
+                  <a16:creationId xmlns:a16="http://schemas.microsoft.com/office/drawing/2014/main" id="{FB9E933E-F738-9B30-FFA9-E1070B197025}"/>
+                </a:ext>
+              </a:extLst>
+            </p:cNvPr>
+            <p:cNvSpPr>
+              <a:spLocks noChangeAspect="1"/>
+            </p:cNvSpPr>
+            <p:nvPr/>
+          </p:nvSpPr>
+          <p:spPr>
+            <a:xfrm>
+              <a:off x="7171369" y="3563365"/>
+              <a:ext cx="110355" cy="108000"/>
+            </a:xfrm>
+            <a:prstGeom prst="ellipse">
+              <a:avLst/>
+            </a:prstGeom>
+            <a:ln>
+              <a:solidFill>
+                <a:schemeClr val="tx2">
+                  <a:lumMod val="75000"/>
+                  <a:lumOff val="25000"/>
+                </a:schemeClr>
+              </a:solidFill>
+            </a:ln>
+          </p:spPr>
+          <p:style>
+            <a:lnRef idx="2">
+              <a:schemeClr val="accent1">
+                <a:shade val="15000"/>
               </a:schemeClr>
-            </a:solidFill>
-          </a:ln>
-        </p:spPr>
-        <p:style>
-          <a:lnRef idx="2">
-            <a:schemeClr val="accent1">
-              <a:shade val="15000"/>
-            </a:schemeClr>
-          </a:lnRef>
-          <a:fillRef idx="1">
-            <a:schemeClr val="accent1"/>
-          </a:fillRef>
-          <a:effectRef idx="0">
-            <a:schemeClr val="accent1"/>
-          </a:effectRef>
-          <a:fontRef idx="minor">
-            <a:schemeClr val="lt1"/>
-          </a:fontRef>
-        </p:style>
-        <p:txBody>
-          <a:bodyPr rtlCol="0" anchor="ctr"/>
-          <a:lstStyle/>
-          <a:p>
-            <a:pPr algn="ctr"/>
-            <a:endParaRPr lang="en-US"/>
-          </a:p>
-        </p:txBody>
-      </p:sp>
-      <p:sp>
-        <p:nvSpPr>
-          <p:cNvPr id="20" name="Oval 19">
-            <a:extLst>
-              <a:ext uri="{FF2B5EF4-FFF2-40B4-BE49-F238E27FC236}">
-                <a16:creationId xmlns:a16="http://schemas.microsoft.com/office/drawing/2014/main" id="{EEB09F32-8250-59E3-5820-CBA1FB59A66D}"/>
-              </a:ext>
-            </a:extLst>
-          </p:cNvPr>
-          <p:cNvSpPr>
-            <a:spLocks noChangeAspect="1"/>
-          </p:cNvSpPr>
-          <p:nvPr/>
-        </p:nvSpPr>
-        <p:spPr>
-          <a:xfrm>
-            <a:off x="5458258" y="3455365"/>
-            <a:ext cx="110355" cy="108000"/>
-          </a:xfrm>
-          <a:prstGeom prst="ellipse">
-            <a:avLst/>
-          </a:prstGeom>
-          <a:ln>
-            <a:solidFill>
-              <a:schemeClr val="tx2">
-                <a:lumMod val="75000"/>
-                <a:lumOff val="25000"/>
+            </a:lnRef>
+            <a:fillRef idx="1">
+              <a:schemeClr val="accent1"/>
+            </a:fillRef>
+            <a:effectRef idx="0">
+              <a:schemeClr val="accent1"/>
+            </a:effectRef>
+            <a:fontRef idx="minor">
+              <a:schemeClr val="lt1"/>
+            </a:fontRef>
+          </p:style>
+          <p:txBody>
+            <a:bodyPr rtlCol="0" anchor="ctr"/>
+            <a:lstStyle/>
+            <a:p>
+              <a:pPr algn="ctr"/>
+              <a:endParaRPr lang="en-US"/>
+            </a:p>
+          </p:txBody>
+        </p:sp>
+        <p:sp>
+          <p:nvSpPr>
+            <p:cNvPr id="23" name="Circular Arrow 22">
+              <a:extLst>
+                <a:ext uri="{FF2B5EF4-FFF2-40B4-BE49-F238E27FC236}">
+                  <a16:creationId xmlns:a16="http://schemas.microsoft.com/office/drawing/2014/main" id="{0ADF2A9D-A4AA-4BD8-C20D-39F4702C6EDE}"/>
+                </a:ext>
+              </a:extLst>
+            </p:cNvPr>
+            <p:cNvSpPr/>
+            <p:nvPr/>
+          </p:nvSpPr>
+          <p:spPr>
+            <a:xfrm rot="15957892">
+              <a:off x="4620914" y="2982162"/>
+              <a:ext cx="469232" cy="846767"/>
+            </a:xfrm>
+            <a:prstGeom prst="circularArrow">
+              <a:avLst>
+                <a:gd name="adj1" fmla="val 10859"/>
+                <a:gd name="adj2" fmla="val 1142319"/>
+                <a:gd name="adj3" fmla="val 21277177"/>
+                <a:gd name="adj4" fmla="val 10303396"/>
+                <a:gd name="adj5" fmla="val 0"/>
+              </a:avLst>
+            </a:prstGeom>
+            <a:ln>
+              <a:solidFill>
+                <a:schemeClr val="tx2">
+                  <a:lumMod val="75000"/>
+                  <a:lumOff val="25000"/>
+                </a:schemeClr>
+              </a:solidFill>
+            </a:ln>
+          </p:spPr>
+          <p:style>
+            <a:lnRef idx="2">
+              <a:schemeClr val="accent1">
+                <a:shade val="15000"/>
               </a:schemeClr>
-            </a:solidFill>
-          </a:ln>
-        </p:spPr>
-        <p:style>
-          <a:lnRef idx="2">
-            <a:schemeClr val="accent1">
-              <a:shade val="15000"/>
-            </a:schemeClr>
-          </a:lnRef>
-          <a:fillRef idx="1">
-            <a:schemeClr val="accent1"/>
-          </a:fillRef>
-          <a:effectRef idx="0">
-            <a:schemeClr val="accent1"/>
-          </a:effectRef>
-          <a:fontRef idx="minor">
-            <a:schemeClr val="lt1"/>
-          </a:fontRef>
-        </p:style>
-        <p:txBody>
-          <a:bodyPr rtlCol="0" anchor="ctr"/>
-          <a:lstStyle/>
-          <a:p>
-            <a:pPr algn="ctr"/>
-            <a:endParaRPr lang="en-US"/>
-          </a:p>
-        </p:txBody>
-      </p:sp>
-      <p:sp>
-        <p:nvSpPr>
-          <p:cNvPr id="21" name="Circular Arrow 20">
-            <a:extLst>
-              <a:ext uri="{FF2B5EF4-FFF2-40B4-BE49-F238E27FC236}">
-                <a16:creationId xmlns:a16="http://schemas.microsoft.com/office/drawing/2014/main" id="{3C2A3DED-BF50-B3D2-555F-09C80CB5E44A}"/>
-              </a:ext>
-            </a:extLst>
-          </p:cNvPr>
-          <p:cNvSpPr/>
-          <p:nvPr/>
-        </p:nvSpPr>
-        <p:spPr>
-          <a:xfrm rot="5219297">
-            <a:off x="7018246" y="2984397"/>
-            <a:ext cx="469232" cy="846767"/>
-          </a:xfrm>
-          <a:prstGeom prst="circularArrow">
-            <a:avLst>
-              <a:gd name="adj1" fmla="val 10859"/>
-              <a:gd name="adj2" fmla="val 1142319"/>
-              <a:gd name="adj3" fmla="val 21277177"/>
-              <a:gd name="adj4" fmla="val 10303396"/>
-              <a:gd name="adj5" fmla="val 0"/>
-            </a:avLst>
-          </a:prstGeom>
-          <a:ln>
-            <a:solidFill>
-              <a:schemeClr val="tx2">
-                <a:lumMod val="75000"/>
-                <a:lumOff val="25000"/>
+            </a:lnRef>
+            <a:fillRef idx="1">
+              <a:schemeClr val="accent1"/>
+            </a:fillRef>
+            <a:effectRef idx="0">
+              <a:schemeClr val="accent1"/>
+            </a:effectRef>
+            <a:fontRef idx="minor">
+              <a:schemeClr val="lt1"/>
+            </a:fontRef>
+          </p:style>
+          <p:txBody>
+            <a:bodyPr rtlCol="0" anchor="ctr"/>
+            <a:lstStyle/>
+            <a:p>
+              <a:pPr algn="ctr"/>
+              <a:endParaRPr lang="en-US">
+                <a:solidFill>
+                  <a:schemeClr val="tx1"/>
+                </a:solidFill>
+              </a:endParaRPr>
+            </a:p>
+          </p:txBody>
+        </p:sp>
+        <p:sp>
+          <p:nvSpPr>
+            <p:cNvPr id="24" name="Oval 23">
+              <a:extLst>
+                <a:ext uri="{FF2B5EF4-FFF2-40B4-BE49-F238E27FC236}">
+                  <a16:creationId xmlns:a16="http://schemas.microsoft.com/office/drawing/2014/main" id="{25612092-C88E-3CC4-3EAC-1453EA78D8F0}"/>
+                </a:ext>
+              </a:extLst>
+            </p:cNvPr>
+            <p:cNvSpPr>
+              <a:spLocks noChangeAspect="1"/>
+            </p:cNvSpPr>
+            <p:nvPr/>
+          </p:nvSpPr>
+          <p:spPr>
+            <a:xfrm rot="10738595">
+              <a:off x="4824487" y="3124229"/>
+              <a:ext cx="110355" cy="108000"/>
+            </a:xfrm>
+            <a:prstGeom prst="ellipse">
+              <a:avLst/>
+            </a:prstGeom>
+            <a:ln>
+              <a:solidFill>
+                <a:schemeClr val="tx2">
+                  <a:lumMod val="75000"/>
+                  <a:lumOff val="25000"/>
+                </a:schemeClr>
+              </a:solidFill>
+            </a:ln>
+          </p:spPr>
+          <p:style>
+            <a:lnRef idx="2">
+              <a:schemeClr val="accent1">
+                <a:shade val="15000"/>
               </a:schemeClr>
-            </a:solidFill>
-          </a:ln>
-        </p:spPr>
-        <p:style>
-          <a:lnRef idx="2">
-            <a:schemeClr val="accent1">
-              <a:shade val="15000"/>
-            </a:schemeClr>
-          </a:lnRef>
-          <a:fillRef idx="1">
-            <a:schemeClr val="accent1"/>
-          </a:fillRef>
-          <a:effectRef idx="0">
-            <a:schemeClr val="accent1"/>
-          </a:effectRef>
-          <a:fontRef idx="minor">
-            <a:schemeClr val="lt1"/>
-          </a:fontRef>
-        </p:style>
-        <p:txBody>
-          <a:bodyPr rtlCol="0" anchor="ctr"/>
-          <a:lstStyle/>
-          <a:p>
-            <a:pPr algn="ctr"/>
-            <a:endParaRPr lang="en-US">
-              <a:solidFill>
-                <a:schemeClr val="tx1"/>
-              </a:solidFill>
-            </a:endParaRPr>
-          </a:p>
-        </p:txBody>
-      </p:sp>
-      <p:sp>
-        <p:nvSpPr>
-          <p:cNvPr id="22" name="Oval 21">
-            <a:extLst>
-              <a:ext uri="{FF2B5EF4-FFF2-40B4-BE49-F238E27FC236}">
-                <a16:creationId xmlns:a16="http://schemas.microsoft.com/office/drawing/2014/main" id="{FB9E933E-F738-9B30-FFA9-E1070B197025}"/>
-              </a:ext>
-            </a:extLst>
-          </p:cNvPr>
-          <p:cNvSpPr>
-            <a:spLocks noChangeAspect="1"/>
-          </p:cNvSpPr>
-          <p:nvPr/>
-        </p:nvSpPr>
-        <p:spPr>
-          <a:xfrm>
-            <a:off x="7171369" y="3563365"/>
-            <a:ext cx="110355" cy="108000"/>
-          </a:xfrm>
-          <a:prstGeom prst="ellipse">
-            <a:avLst/>
-          </a:prstGeom>
-          <a:ln>
-            <a:solidFill>
-              <a:schemeClr val="tx2">
-                <a:lumMod val="75000"/>
-                <a:lumOff val="25000"/>
-              </a:schemeClr>
-            </a:solidFill>
-          </a:ln>
-        </p:spPr>
-        <p:style>
-          <a:lnRef idx="2">
-            <a:schemeClr val="accent1">
-              <a:shade val="15000"/>
-            </a:schemeClr>
-          </a:lnRef>
-          <a:fillRef idx="1">
-            <a:schemeClr val="accent1"/>
-          </a:fillRef>
-          <a:effectRef idx="0">
-            <a:schemeClr val="accent1"/>
-          </a:effectRef>
-          <a:fontRef idx="minor">
-            <a:schemeClr val="lt1"/>
-          </a:fontRef>
-        </p:style>
-        <p:txBody>
-          <a:bodyPr rtlCol="0" anchor="ctr"/>
-          <a:lstStyle/>
-          <a:p>
-            <a:pPr algn="ctr"/>
-            <a:endParaRPr lang="en-US"/>
-          </a:p>
-        </p:txBody>
-      </p:sp>
-      <p:sp>
-        <p:nvSpPr>
-          <p:cNvPr id="23" name="Circular Arrow 22">
-            <a:extLst>
-              <a:ext uri="{FF2B5EF4-FFF2-40B4-BE49-F238E27FC236}">
-                <a16:creationId xmlns:a16="http://schemas.microsoft.com/office/drawing/2014/main" id="{0ADF2A9D-A4AA-4BD8-C20D-39F4702C6EDE}"/>
-              </a:ext>
-            </a:extLst>
-          </p:cNvPr>
-          <p:cNvSpPr/>
-          <p:nvPr/>
-        </p:nvSpPr>
-        <p:spPr>
-          <a:xfrm rot="15957892">
-            <a:off x="4620914" y="2982162"/>
-            <a:ext cx="469232" cy="846767"/>
-          </a:xfrm>
-          <a:prstGeom prst="circularArrow">
-            <a:avLst>
-              <a:gd name="adj1" fmla="val 10859"/>
-              <a:gd name="adj2" fmla="val 1142319"/>
-              <a:gd name="adj3" fmla="val 21277177"/>
-              <a:gd name="adj4" fmla="val 10303396"/>
-              <a:gd name="adj5" fmla="val 0"/>
-            </a:avLst>
-          </a:prstGeom>
-          <a:ln>
-            <a:solidFill>
-              <a:schemeClr val="tx2">
-                <a:lumMod val="75000"/>
-                <a:lumOff val="25000"/>
-              </a:schemeClr>
-            </a:solidFill>
-          </a:ln>
-        </p:spPr>
-        <p:style>
-          <a:lnRef idx="2">
-            <a:schemeClr val="accent1">
-              <a:shade val="15000"/>
-            </a:schemeClr>
-          </a:lnRef>
-          <a:fillRef idx="1">
-            <a:schemeClr val="accent1"/>
-          </a:fillRef>
-          <a:effectRef idx="0">
-            <a:schemeClr val="accent1"/>
-          </a:effectRef>
-          <a:fontRef idx="minor">
-            <a:schemeClr val="lt1"/>
-          </a:fontRef>
-        </p:style>
-        <p:txBody>
-          <a:bodyPr rtlCol="0" anchor="ctr"/>
-          <a:lstStyle/>
-          <a:p>
-            <a:pPr algn="ctr"/>
-            <a:endParaRPr lang="en-US">
-              <a:solidFill>
-                <a:schemeClr val="tx1"/>
-              </a:solidFill>
-            </a:endParaRPr>
-          </a:p>
-        </p:txBody>
-      </p:sp>
-      <p:sp>
-        <p:nvSpPr>
-          <p:cNvPr id="24" name="Oval 23">
-            <a:extLst>
-              <a:ext uri="{FF2B5EF4-FFF2-40B4-BE49-F238E27FC236}">
-                <a16:creationId xmlns:a16="http://schemas.microsoft.com/office/drawing/2014/main" id="{25612092-C88E-3CC4-3EAC-1453EA78D8F0}"/>
-              </a:ext>
-            </a:extLst>
-          </p:cNvPr>
-          <p:cNvSpPr>
-            <a:spLocks noChangeAspect="1"/>
-          </p:cNvSpPr>
-          <p:nvPr/>
-        </p:nvSpPr>
-        <p:spPr>
-          <a:xfrm rot="10738595">
-            <a:off x="4824487" y="3124229"/>
-            <a:ext cx="110355" cy="108000"/>
-          </a:xfrm>
-          <a:prstGeom prst="ellipse">
-            <a:avLst/>
-          </a:prstGeom>
-          <a:ln>
-            <a:solidFill>
-              <a:schemeClr val="tx2">
-                <a:lumMod val="75000"/>
-                <a:lumOff val="25000"/>
-              </a:schemeClr>
-            </a:solidFill>
-          </a:ln>
-        </p:spPr>
-        <p:style>
-          <a:lnRef idx="2">
-            <a:schemeClr val="accent1">
-              <a:shade val="15000"/>
-            </a:schemeClr>
-          </a:lnRef>
-          <a:fillRef idx="1">
-            <a:schemeClr val="accent1"/>
-          </a:fillRef>
-          <a:effectRef idx="0">
-            <a:schemeClr val="accent1"/>
-          </a:effectRef>
-          <a:fontRef idx="minor">
-            <a:schemeClr val="lt1"/>
-          </a:fontRef>
-        </p:style>
-        <p:txBody>
-          <a:bodyPr rtlCol="0" anchor="ctr"/>
-          <a:lstStyle/>
-          <a:p>
-            <a:pPr algn="ctr"/>
-            <a:endParaRPr lang="en-US"/>
-          </a:p>
-        </p:txBody>
-      </p:sp>
+            </a:lnRef>
+            <a:fillRef idx="1">
+              <a:schemeClr val="accent1"/>
+            </a:fillRef>
+            <a:effectRef idx="0">
+              <a:schemeClr val="accent1"/>
+            </a:effectRef>
+            <a:fontRef idx="minor">
+              <a:schemeClr val="lt1"/>
+            </a:fontRef>
+          </p:style>
+          <p:txBody>
+            <a:bodyPr rtlCol="0" anchor="ctr"/>
+            <a:lstStyle/>
+            <a:p>
+              <a:pPr algn="ctr"/>
+              <a:endParaRPr lang="en-US"/>
+            </a:p>
+          </p:txBody>
+        </p:sp>
+      </p:grpSp>
     </p:spTree>
     <p:extLst>
       <p:ext uri="{BB962C8B-B14F-4D97-AF65-F5344CB8AC3E}">

</xml_diff>